<commit_message>
feat(video): script v3 client + slide ROI + Niamato Consulting
Audit complet cahier des charges, 7 corrections:
- Ajout Niamato Consulting (entreprise) dans slides, footer, bandeaux
- Nouvelle slide ROI (temps x10, volume x200, risque -67%, cout ~0)
- Script v3 reframe "client" (plus "jury academique")
- Section contexte client + besoin business ajoutee
- Numerotation slides synchro script<->PPTX (17 slides)
- Architecture: mention "Donnees -> IA -> Decision" explicite
- Valorisation dataviz dans section demo dashboard
- Inclusion fichiers pre-tournage, Q&R defensif, specs keynote
</commit_message>
<xml_diff>
--- a/video_mvp/Thumalien_V9_slides.pptx
+++ b/video_mvp/Thumalien_V9_slides.pptx
@@ -21,6 +21,7 @@
     <p:sldId id="269" r:id="rId21"/>
     <p:sldId id="270" r:id="rId22"/>
     <p:sldId id="271" r:id="rId23"/>
+    <p:sldId id="272" r:id="rId24"/>
   </p:sldIdLst>
   <p:sldSz cx="12191695" cy="6858000" type="screen4x3"/>
   <p:notesSz cx="6858000" cy="9144000"/>
@@ -1161,69 +1162,48 @@
           <a:lstStyle/>
           <a:p>
             <a:r>
-              <a:t>SLIDE 12 — ROADMAP (14:30 → 16:30)</a:t>
-            </a:r>
-          </a:p>
-          <a:p>
-            <a:r>
-              <a:t>Timing : 2 minutes</a:t>
+              <a:t>SLIDE 14 — ROI (15:45 → 16:30)</a:t>
+            </a:r>
+          </a:p>
+          <a:p>
+            <a:r>
+              <a:t>Speaker : SÉBASTIEN</a:t>
+            </a:r>
+          </a:p>
+          <a:p>
+            <a:r>
+              <a:t>Timing : 45 secondes</a:t>
             </a:r>
           </a:p>
           <a:p/>
           <a:p>
             <a:r>
-              <a:t>Texte voix-off :</a:t>
-            </a:r>
-          </a:p>
-          <a:p>
-            <a:r>
-              <a:t>« Nous sommes lucides sur les limites de V9.</a:t>
-            </a:r>
-          </a:p>
-          <a:p>
-            <a:r>
-              <a:t>La roadmap est structurée en 3 phases.</a:t>
-            </a:r>
-          </a:p>
-          <a:p>
-            <a:r>
-              <a:t>V10 au troisième trimestre 2026 : industrialisation avec MLflow pour le tracking</a:t>
-            </a:r>
-          </a:p>
-          <a:p>
-            <a:r>
-              <a:t>d'expériences et monitoring de drift.</a:t>
-            </a:r>
-          </a:p>
-          <a:p>
-            <a:r>
-              <a:t>V11 fin 2026 : intégration de ClaimBuster pour la vérification factuelle,</a:t>
-            </a:r>
-          </a:p>
-          <a:p>
-            <a:r>
-              <a:t>monitoring Grafana, et tests end-to-end automatisés chaque nuit.</a:t>
-            </a:r>
-          </a:p>
-          <a:p>
-            <a:r>
-              <a:t>V12 en 2027 : un modèle spécialisé français, de l'annotation communautaire,</a:t>
-            </a:r>
-          </a:p>
-          <a:p>
-            <a:r>
-              <a:t>et du federated learning pour l'inclusion.</a:t>
-            </a:r>
-          </a:p>
-          <a:p>
-            <a:r>
-              <a:t>Chaque version a un thème clair et des livrables concrets. »</a:t>
-            </a:r>
-          </a:p>
-          <a:p/>
-          <a:p>
-            <a:r>
-              <a:t>Point clé : montrer qu'on sait où on va, sans sur-promettre.</a:t>
+              <a:t>Texte voix-off (Sébastien) :</a:t>
+            </a:r>
+          </a:p>
+          <a:p>
+            <a:r>
+              <a:t>« Voici le retour sur investissement concret.</a:t>
+            </a:r>
+          </a:p>
+          <a:p>
+            <a:r>
+              <a:t>En temps : un modérateur passe de 5 minutes à 30 secondes par post.</a:t>
+            </a:r>
+          </a:p>
+          <a:p>
+            <a:r>
+              <a:t>En volume : 60 000 posts par jour traités automatiquement.</a:t>
+            </a:r>
+          </a:p>
+          <a:p>
+            <a:r>
+              <a:t>En risque : conformité AI Act intégrée, faux positifs réduits de 67 %.</a:t>
+            </a:r>
+          </a:p>
+          <a:p>
+            <a:r>
+              <a:t>En coût : hébergé sur une machine à 22 watts, coût marginal quasi nul. »</a:t>
             </a:r>
           </a:p>
         </p:txBody>
@@ -1293,45 +1273,69 @@
           <a:lstStyle/>
           <a:p>
             <a:r>
-              <a:t>SLIDE 13 — CITATION (17:30 → 17:45)</a:t>
-            </a:r>
-          </a:p>
-          <a:p>
-            <a:r>
-              <a:t>Timing : 15 secondes — SILENCE après avoir prononcé la phrase</a:t>
+              <a:t>SLIDE 12 — ROADMAP (14:30 → 16:30)</a:t>
+            </a:r>
+          </a:p>
+          <a:p>
+            <a:r>
+              <a:t>Timing : 2 minutes</a:t>
             </a:r>
           </a:p>
           <a:p/>
           <a:p>
             <a:r>
-              <a:t>Animation : la citation reste 5 secondes complètes en silence,</a:t>
-            </a:r>
-          </a:p>
-          <a:p>
-            <a:r>
-              <a:t>puis fondu enchaîné de 1.5s vers la slide remerciements.</a:t>
+              <a:t>Texte voix-off :</a:t>
+            </a:r>
+          </a:p>
+          <a:p>
+            <a:r>
+              <a:t>« Nous sommes lucides sur les limites de V9.</a:t>
+            </a:r>
+          </a:p>
+          <a:p>
+            <a:r>
+              <a:t>La roadmap est structurée en 3 phases.</a:t>
+            </a:r>
+          </a:p>
+          <a:p>
+            <a:r>
+              <a:t>V10 au troisième trimestre 2026 : industrialisation avec MLflow pour le tracking</a:t>
+            </a:r>
+          </a:p>
+          <a:p>
+            <a:r>
+              <a:t>d'expériences et monitoring de drift.</a:t>
+            </a:r>
+          </a:p>
+          <a:p>
+            <a:r>
+              <a:t>V11 fin 2026 : intégration de ClaimBuster pour la vérification factuelle,</a:t>
+            </a:r>
+          </a:p>
+          <a:p>
+            <a:r>
+              <a:t>monitoring Grafana, et tests end-to-end automatisés chaque nuit.</a:t>
+            </a:r>
+          </a:p>
+          <a:p>
+            <a:r>
+              <a:t>V12 en 2027 : un modèle spécialisé français, de l'annotation communautaire,</a:t>
+            </a:r>
+          </a:p>
+          <a:p>
+            <a:r>
+              <a:t>et du federated learning pour l'inclusion.</a:t>
+            </a:r>
+          </a:p>
+          <a:p>
+            <a:r>
+              <a:t>Chaque version a un thème clair et des livrables concrets. »</a:t>
             </a:r>
           </a:p>
           <a:p/>
           <a:p>
             <a:r>
-              <a:t>Texte voix-off (prononcé lentement, regard caméra) :</a:t>
-            </a:r>
-          </a:p>
-          <a:p>
-            <a:r>
-              <a:t>« Un score sans explication est un verdict sans procès. »</a:t>
-            </a:r>
-          </a:p>
-          <a:p>
-            <a:r>
-              <a:t>[SILENCE 5 secondes — laisser résonner]</a:t>
-            </a:r>
-          </a:p>
-          <a:p/>
-          <a:p>
-            <a:r>
-              <a:t>Ce silence renforce l'impact. Ne rien ajouter.</a:t>
+              <a:t>Point clé : montrer qu'on sait où on va, sans sur-promettre.</a:t>
             </a:r>
           </a:p>
         </p:txBody>
@@ -1357,6 +1361,114 @@
 </file>
 
 <file path=ppt/notesSlides/notesSlide16.xml><?xml version="1.0" encoding="utf-8"?>
+<p:notes xmlns:a="http://schemas.openxmlformats.org/drawingml/2006/main" xmlns:p="http://schemas.openxmlformats.org/presentationml/2006/main" xmlns:r="http://schemas.openxmlformats.org/officeDocument/2006/relationships">
+  <p:cSld>
+    <p:spTree>
+      <p:nvGrpSpPr>
+        <p:cNvPr id="1" name=""/>
+        <p:cNvGrpSpPr/>
+        <p:nvPr/>
+      </p:nvGrpSpPr>
+      <p:grpSpPr>
+        <a:xfrm>
+          <a:off x="0" y="0"/>
+          <a:ext cx="0" cy="0"/>
+          <a:chOff x="0" y="0"/>
+          <a:chExt cx="0" cy="0"/>
+        </a:xfrm>
+      </p:grpSpPr>
+      <p:sp>
+        <p:nvSpPr>
+          <p:cNvPr id="2" name="Slide Image Placeholder 1"/>
+          <p:cNvSpPr>
+            <a:spLocks noGrp="1"/>
+          </p:cNvSpPr>
+          <p:nvPr>
+            <p:ph type="sldImg" idx="2"/>
+          </p:nvPr>
+        </p:nvSpPr>
+        <p:spPr/>
+      </p:sp>
+      <p:sp>
+        <p:nvSpPr>
+          <p:cNvPr id="3" name="Notes Placeholder 2"/>
+          <p:cNvSpPr>
+            <a:spLocks noGrp="1"/>
+          </p:cNvSpPr>
+          <p:nvPr>
+            <p:ph type="body" idx="3" sz="quarter"/>
+          </p:nvPr>
+        </p:nvSpPr>
+        <p:spPr/>
+        <p:txBody>
+          <a:bodyPr/>
+          <a:lstStyle/>
+          <a:p>
+            <a:r>
+              <a:t>SLIDE 13 — CITATION (17:30 → 17:45)</a:t>
+            </a:r>
+          </a:p>
+          <a:p>
+            <a:r>
+              <a:t>Timing : 15 secondes — SILENCE après avoir prononcé la phrase</a:t>
+            </a:r>
+          </a:p>
+          <a:p/>
+          <a:p>
+            <a:r>
+              <a:t>Animation : la citation reste 5 secondes complètes en silence,</a:t>
+            </a:r>
+          </a:p>
+          <a:p>
+            <a:r>
+              <a:t>puis fondu enchaîné de 1.5s vers la slide remerciements.</a:t>
+            </a:r>
+          </a:p>
+          <a:p/>
+          <a:p>
+            <a:r>
+              <a:t>Texte voix-off (prononcé lentement, regard caméra) :</a:t>
+            </a:r>
+          </a:p>
+          <a:p>
+            <a:r>
+              <a:t>« Un score sans explication est un verdict sans procès. »</a:t>
+            </a:r>
+          </a:p>
+          <a:p>
+            <a:r>
+              <a:t>[SILENCE 5 secondes — laisser résonner]</a:t>
+            </a:r>
+          </a:p>
+          <a:p/>
+          <a:p>
+            <a:r>
+              <a:t>Ce silence renforce l'impact. Ne rien ajouter.</a:t>
+            </a:r>
+          </a:p>
+        </p:txBody>
+      </p:sp>
+      <p:sp>
+        <p:nvSpPr>
+          <p:cNvPr id="4" name="Slide Number Placeholder 3"/>
+          <p:cNvSpPr>
+            <a:spLocks noGrp="1"/>
+          </p:cNvSpPr>
+          <p:nvPr>
+            <p:ph type="sldNum" idx="5" sz="quarter"/>
+          </p:nvPr>
+        </p:nvSpPr>
+        <p:spPr/>
+      </p:sp>
+    </p:spTree>
+  </p:cSld>
+  <p:clrMapOvr>
+    <a:masterClrMapping/>
+  </p:clrMapOvr>
+</p:notes>
+</file>
+
+<file path=ppt/notesSlides/notesSlide17.xml><?xml version="1.0" encoding="utf-8"?>
 <p:notes xmlns:a="http://schemas.openxmlformats.org/drawingml/2006/main" xmlns:p="http://schemas.openxmlformats.org/presentationml/2006/main" xmlns:r="http://schemas.openxmlformats.org/officeDocument/2006/relationships">
   <p:cSld>
     <p:spTree>
@@ -5620,7 +5732,47 @@
         </p:nvSpPr>
         <p:spPr>
           <a:xfrm>
-            <a:off x="914400" y="4023360"/>
+            <a:off x="914400" y="3840480"/>
+            <a:ext cx="10332720" cy="411480"/>
+          </a:xfrm>
+          <a:prstGeom prst="rect">
+            <a:avLst/>
+          </a:prstGeom>
+          <a:noFill/>
+        </p:spPr>
+        <p:txBody>
+          <a:bodyPr wrap="square"/>
+          <a:lstStyle/>
+          <a:p>
+            <a:pPr algn="ctr">
+              <a:spcBef>
+                <a:spcPts val="200"/>
+              </a:spcBef>
+              <a:spcAft>
+                <a:spcPts val="200"/>
+              </a:spcAft>
+              <a:defRPr sz="2200" b="1" i="0">
+                <a:solidFill>
+                  <a:srgbClr val="00E676"/>
+                </a:solidFill>
+                <a:latin typeface="Inter"/>
+              </a:defRPr>
+            </a:pPr>
+            <a:r>
+              <a:t>NIAMATO CONSULTING</a:t>
+            </a:r>
+          </a:p>
+        </p:txBody>
+      </p:sp>
+      <p:sp>
+        <p:nvSpPr>
+          <p:cNvPr id="7" name="TextBox 6"/>
+          <p:cNvSpPr txBox="1"/>
+          <p:nvPr/>
+        </p:nvSpPr>
+        <p:spPr>
+          <a:xfrm>
+            <a:off x="914400" y="4297680"/>
             <a:ext cx="10332720" cy="502920"/>
           </a:xfrm>
           <a:prstGeom prst="rect">
@@ -5654,13 +5806,13 @@
       </p:sp>
       <p:sp>
         <p:nvSpPr>
-          <p:cNvPr id="7" name="TextBox 6"/>
-          <p:cNvSpPr txBox="1"/>
-          <p:nvPr/>
-        </p:nvSpPr>
-        <p:spPr>
-          <a:xfrm>
-            <a:off x="914400" y="4663440"/>
+          <p:cNvPr id="8" name="TextBox 7"/>
+          <p:cNvSpPr txBox="1"/>
+          <p:nvPr/>
+        </p:nvSpPr>
+        <p:spPr>
+          <a:xfrm>
+            <a:off x="914400" y="4846320"/>
             <a:ext cx="10332720" cy="365760"/>
           </a:xfrm>
           <a:prstGeom prst="rect">
@@ -5694,7 +5846,7 @@
       </p:sp>
       <p:sp>
         <p:nvSpPr>
-          <p:cNvPr id="8" name="Rectangle 7"/>
+          <p:cNvPr id="9" name="Rectangle 8"/>
           <p:cNvSpPr/>
           <p:nvPr/>
         </p:nvSpPr>
@@ -5737,7 +5889,7 @@
       </p:sp>
       <p:sp>
         <p:nvSpPr>
-          <p:cNvPr id="9" name="TextBox 8"/>
+          <p:cNvPr id="10" name="TextBox 9"/>
           <p:cNvSpPr txBox="1"/>
           <p:nvPr/>
         </p:nvSpPr>
@@ -5777,7 +5929,7 @@
       </p:sp>
       <p:sp>
         <p:nvSpPr>
-          <p:cNvPr id="10" name="TextBox 9"/>
+          <p:cNvPr id="11" name="TextBox 10"/>
           <p:cNvSpPr txBox="1"/>
           <p:nvPr/>
         </p:nvSpPr>
@@ -5806,14 +5958,14 @@
               </a:defRPr>
             </a:pPr>
             <a:r>
-              <a:t>Thumalien V9  ·  M1 BDIA 2026</a:t>
-            </a:r>
-          </a:p>
-        </p:txBody>
-      </p:sp>
-      <p:sp>
-        <p:nvSpPr>
-          <p:cNvPr id="11" name="TextBox 10"/>
+              <a:t>Niamato Consulting  ·  Thumalien V9  ·  M1 BDIA 2026</a:t>
+            </a:r>
+          </a:p>
+        </p:txBody>
+      </p:sp>
+      <p:sp>
+        <p:nvSpPr>
+          <p:cNvPr id="12" name="TextBox 11"/>
           <p:cNvSpPr txBox="1"/>
           <p:nvPr/>
         </p:nvSpPr>
@@ -5842,7 +5994,7 @@
               </a:defRPr>
             </a:pPr>
             <a:r>
-              <a:t>1 / 16</a:t>
+              <a:t>1 / 17</a:t>
             </a:r>
           </a:p>
         </p:txBody>
@@ -6724,7 +6876,7 @@
               </a:defRPr>
             </a:pPr>
             <a:r>
-              <a:t>Thumalien V9  ·  M1 BDIA 2026</a:t>
+              <a:t>Niamato Consulting  ·  Thumalien V9  ·  M1 BDIA 2026</a:t>
             </a:r>
           </a:p>
         </p:txBody>
@@ -6760,7 +6912,7 @@
               </a:defRPr>
             </a:pPr>
             <a:r>
-              <a:t>10 / 16</a:t>
+              <a:t>10 / 17</a:t>
             </a:r>
           </a:p>
         </p:txBody>
@@ -7830,7 +7982,7 @@
               </a:defRPr>
             </a:pPr>
             <a:r>
-              <a:t>Thumalien V9  ·  M1 BDIA 2026</a:t>
+              <a:t>Niamato Consulting  ·  Thumalien V9  ·  M1 BDIA 2026</a:t>
             </a:r>
           </a:p>
         </p:txBody>
@@ -7866,7 +8018,7 @@
               </a:defRPr>
             </a:pPr>
             <a:r>
-              <a:t>11 / 16</a:t>
+              <a:t>11 / 17</a:t>
             </a:r>
           </a:p>
         </p:txBody>
@@ -9335,7 +9487,7 @@
               </a:defRPr>
             </a:pPr>
             <a:r>
-              <a:t>Thumalien V9  ·  M1 BDIA 2026</a:t>
+              <a:t>Niamato Consulting  ·  Thumalien V9  ·  M1 BDIA 2026</a:t>
             </a:r>
           </a:p>
         </p:txBody>
@@ -9371,7 +9523,7 @@
               </a:defRPr>
             </a:pPr>
             <a:r>
-              <a:t>12 / 16</a:t>
+              <a:t>12 / 17</a:t>
             </a:r>
           </a:p>
         </p:txBody>
@@ -11172,7 +11324,7 @@
               </a:defRPr>
             </a:pPr>
             <a:r>
-              <a:t>Thumalien V9  ·  M1 BDIA 2026</a:t>
+              <a:t>Niamato Consulting  ·  Thumalien V9  ·  M1 BDIA 2026</a:t>
             </a:r>
           </a:p>
         </p:txBody>
@@ -11208,7 +11360,7 @@
               </a:defRPr>
             </a:pPr>
             <a:r>
-              <a:t>13 / 16</a:t>
+              <a:t>13 / 17</a:t>
             </a:r>
           </a:p>
         </p:txBody>
@@ -11267,67 +11419,27 @@
               </a:spcAft>
               <a:defRPr sz="4400" b="1">
                 <a:solidFill>
-                  <a:srgbClr val="00D4FF"/>
-                </a:solidFill>
-                <a:latin typeface="Inter"/>
-              </a:defRPr>
-            </a:pPr>
-            <a:r>
-              <a:t>ROADMAP — VERS V12</a:t>
-            </a:r>
-          </a:p>
-        </p:txBody>
-      </p:sp>
-      <p:sp>
-        <p:nvSpPr>
-          <p:cNvPr id="3" name="TextBox 2"/>
-          <p:cNvSpPr txBox="1"/>
-          <p:nvPr/>
-        </p:nvSpPr>
-        <p:spPr>
-          <a:xfrm>
-            <a:off x="731520" y="868680"/>
-            <a:ext cx="10058400" cy="365760"/>
-          </a:xfrm>
-          <a:prstGeom prst="rect">
-            <a:avLst/>
-          </a:prstGeom>
-          <a:noFill/>
-        </p:spPr>
-        <p:txBody>
-          <a:bodyPr wrap="square"/>
-          <a:lstStyle/>
-          <a:p>
-            <a:pPr algn="l">
-              <a:spcBef>
-                <a:spcPts val="200"/>
-              </a:spcBef>
-              <a:spcAft>
-                <a:spcPts val="200"/>
-              </a:spcAft>
-              <a:defRPr sz="2200" b="0" i="0">
-                <a:solidFill>
-                  <a:srgbClr val="B0B0B0"/>
-                </a:solidFill>
-                <a:latin typeface="Inter"/>
-              </a:defRPr>
-            </a:pPr>
-            <a:r>
-              <a:t>Limites assumées et perspectives</a:t>
-            </a:r>
-          </a:p>
-        </p:txBody>
-      </p:sp>
-      <p:sp>
-        <p:nvSpPr>
-          <p:cNvPr id="4" name="Rounded Rectangle 3"/>
+                  <a:srgbClr val="FFD600"/>
+                </a:solidFill>
+                <a:latin typeface="Inter"/>
+              </a:defRPr>
+            </a:pPr>
+            <a:r>
+              <a:t>ROI — VALEUR BUSINESS</a:t>
+            </a:r>
+          </a:p>
+        </p:txBody>
+      </p:sp>
+      <p:sp>
+        <p:nvSpPr>
+          <p:cNvPr id="3" name="Rounded Rectangle 2"/>
           <p:cNvSpPr/>
           <p:nvPr/>
         </p:nvSpPr>
         <p:spPr>
           <a:xfrm>
             <a:off x="457200" y="1371600"/>
-            <a:ext cx="3474720" cy="4754880"/>
+            <a:ext cx="2697480" cy="4389120"/>
           </a:xfrm>
           <a:prstGeom prst="roundRect">
             <a:avLst>
@@ -11367,14 +11479,14 @@
       </p:sp>
       <p:sp>
         <p:nvSpPr>
-          <p:cNvPr id="5" name="TextBox 4"/>
+          <p:cNvPr id="4" name="TextBox 3"/>
           <p:cNvSpPr txBox="1"/>
           <p:nvPr/>
         </p:nvSpPr>
         <p:spPr>
           <a:xfrm>
             <a:off x="548640" y="1554480"/>
-            <a:ext cx="3291840" cy="548640"/>
+            <a:ext cx="2514600" cy="320040"/>
           </a:xfrm>
           <a:prstGeom prst="rect">
             <a:avLst/>
@@ -11392,7 +11504,7 @@
               <a:spcAft>
                 <a:spcPts val="200"/>
               </a:spcAft>
-              <a:defRPr sz="4000" b="1" i="0">
+              <a:defRPr sz="1600" b="1" i="0">
                 <a:solidFill>
                   <a:srgbClr val="00D4FF"/>
                 </a:solidFill>
@@ -11400,61 +11512,21 @@
               </a:defRPr>
             </a:pPr>
             <a:r>
-              <a:t>V10</a:t>
-            </a:r>
-          </a:p>
-        </p:txBody>
-      </p:sp>
-      <p:sp>
-        <p:nvSpPr>
-          <p:cNvPr id="6" name="TextBox 5"/>
-          <p:cNvSpPr txBox="1"/>
-          <p:nvPr/>
-        </p:nvSpPr>
-        <p:spPr>
-          <a:xfrm>
-            <a:off x="548640" y="2148840"/>
-            <a:ext cx="3291840" cy="320040"/>
-          </a:xfrm>
-          <a:prstGeom prst="rect">
-            <a:avLst/>
-          </a:prstGeom>
-          <a:noFill/>
-        </p:spPr>
-        <p:txBody>
-          <a:bodyPr wrap="square"/>
-          <a:lstStyle/>
-          <a:p>
-            <a:pPr algn="ctr">
-              <a:spcBef>
-                <a:spcPts val="200"/>
-              </a:spcBef>
-              <a:spcAft>
-                <a:spcPts val="200"/>
-              </a:spcAft>
-              <a:defRPr sz="2000" b="0" i="0">
-                <a:solidFill>
-                  <a:srgbClr val="B0B0B0"/>
-                </a:solidFill>
-                <a:latin typeface="Inter"/>
-              </a:defRPr>
-            </a:pPr>
-            <a:r>
-              <a:t>Q3 2026</a:t>
-            </a:r>
-          </a:p>
-        </p:txBody>
-      </p:sp>
-      <p:sp>
-        <p:nvSpPr>
-          <p:cNvPr id="7" name="Rectangle 6"/>
+              <a:t>TEMPS</a:t>
+            </a:r>
+          </a:p>
+        </p:txBody>
+      </p:sp>
+      <p:sp>
+        <p:nvSpPr>
+          <p:cNvPr id="5" name="Rectangle 4"/>
           <p:cNvSpPr/>
           <p:nvPr/>
         </p:nvSpPr>
         <p:spPr>
           <a:xfrm>
-            <a:off x="731520" y="2606040"/>
-            <a:ext cx="2926080" cy="12700"/>
+            <a:off x="731520" y="1965960"/>
+            <a:ext cx="2148840" cy="12700"/>
           </a:xfrm>
           <a:prstGeom prst="rect">
             <a:avLst/>
@@ -11490,217 +11562,132 @@
       </p:sp>
       <p:sp>
         <p:nvSpPr>
-          <p:cNvPr id="8" name="TextBox 7"/>
-          <p:cNvSpPr txBox="1"/>
-          <p:nvPr/>
-        </p:nvSpPr>
-        <p:spPr>
-          <a:xfrm>
-            <a:off x="822960" y="2834640"/>
-            <a:ext cx="2926080" cy="457200"/>
-          </a:xfrm>
-          <a:prstGeom prst="rect">
-            <a:avLst/>
-          </a:prstGeom>
-          <a:noFill/>
-        </p:spPr>
-        <p:txBody>
-          <a:bodyPr wrap="square"/>
-          <a:lstStyle/>
-          <a:p>
-            <a:pPr algn="l">
-              <a:spcBef>
-                <a:spcPts val="200"/>
-              </a:spcBef>
-              <a:spcAft>
-                <a:spcPts val="200"/>
-              </a:spcAft>
-              <a:defRPr sz="1700" b="0" i="0">
-                <a:solidFill>
-                  <a:srgbClr val="E8E8E8"/>
-                </a:solidFill>
-                <a:latin typeface="Inter"/>
-              </a:defRPr>
-            </a:pPr>
-            <a:r>
-              <a:t>•  MLflow tracking</a:t>
-            </a:r>
-          </a:p>
-        </p:txBody>
-      </p:sp>
-      <p:sp>
-        <p:nvSpPr>
-          <p:cNvPr id="9" name="TextBox 8"/>
-          <p:cNvSpPr txBox="1"/>
-          <p:nvPr/>
-        </p:nvSpPr>
-        <p:spPr>
-          <a:xfrm>
-            <a:off x="822960" y="3383280"/>
-            <a:ext cx="2926080" cy="457200"/>
-          </a:xfrm>
-          <a:prstGeom prst="rect">
-            <a:avLst/>
-          </a:prstGeom>
-          <a:noFill/>
-        </p:spPr>
-        <p:txBody>
-          <a:bodyPr wrap="square"/>
-          <a:lstStyle/>
-          <a:p>
-            <a:pPr algn="l">
-              <a:spcBef>
-                <a:spcPts val="200"/>
-              </a:spcBef>
-              <a:spcAft>
-                <a:spcPts val="200"/>
-              </a:spcAft>
-              <a:defRPr sz="1700" b="0" i="0">
-                <a:solidFill>
-                  <a:srgbClr val="E8E8E8"/>
-                </a:solidFill>
-                <a:latin typeface="Inter"/>
-              </a:defRPr>
-            </a:pPr>
-            <a:r>
-              <a:t>•  Drift monitoring</a:t>
-            </a:r>
-          </a:p>
-        </p:txBody>
-      </p:sp>
-      <p:sp>
-        <p:nvSpPr>
-          <p:cNvPr id="10" name="TextBox 9"/>
-          <p:cNvSpPr txBox="1"/>
-          <p:nvPr/>
-        </p:nvSpPr>
-        <p:spPr>
-          <a:xfrm>
-            <a:off x="822960" y="3931920"/>
-            <a:ext cx="2926080" cy="457200"/>
-          </a:xfrm>
-          <a:prstGeom prst="rect">
-            <a:avLst/>
-          </a:prstGeom>
-          <a:noFill/>
-        </p:spPr>
-        <p:txBody>
-          <a:bodyPr wrap="square"/>
-          <a:lstStyle/>
-          <a:p>
-            <a:pPr algn="l">
-              <a:spcBef>
-                <a:spcPts val="200"/>
-              </a:spcBef>
-              <a:spcAft>
-                <a:spcPts val="200"/>
-              </a:spcAft>
-              <a:defRPr sz="1700" b="0" i="0">
-                <a:solidFill>
-                  <a:srgbClr val="E8E8E8"/>
-                </a:solidFill>
-                <a:latin typeface="Inter"/>
-              </a:defRPr>
-            </a:pPr>
-            <a:r>
-              <a:t>•  Streamlit AppTest</a:t>
-            </a:r>
-          </a:p>
-        </p:txBody>
-      </p:sp>
-      <p:sp>
-        <p:nvSpPr>
-          <p:cNvPr id="11" name="Rectangle 10"/>
+          <p:cNvPr id="6" name="TextBox 5"/>
+          <p:cNvSpPr txBox="1"/>
+          <p:nvPr/>
+        </p:nvSpPr>
+        <p:spPr>
+          <a:xfrm>
+            <a:off x="548640" y="2103120"/>
+            <a:ext cx="2514600" cy="1097280"/>
+          </a:xfrm>
+          <a:prstGeom prst="rect">
+            <a:avLst/>
+          </a:prstGeom>
+          <a:noFill/>
+        </p:spPr>
+        <p:txBody>
+          <a:bodyPr wrap="square"/>
+          <a:lstStyle/>
+          <a:p>
+            <a:pPr algn="ctr">
+              <a:spcBef>
+                <a:spcPts val="200"/>
+              </a:spcBef>
+              <a:spcAft>
+                <a:spcPts val="200"/>
+              </a:spcAft>
+              <a:defRPr sz="5600" b="1" i="0">
+                <a:solidFill>
+                  <a:srgbClr val="00D4FF"/>
+                </a:solidFill>
+                <a:latin typeface="Inter"/>
+              </a:defRPr>
+            </a:pPr>
+            <a:r>
+              <a:t>10x</a:t>
+            </a:r>
+          </a:p>
+        </p:txBody>
+      </p:sp>
+      <p:sp>
+        <p:nvSpPr>
+          <p:cNvPr id="7" name="TextBox 6"/>
+          <p:cNvSpPr txBox="1"/>
+          <p:nvPr/>
+        </p:nvSpPr>
+        <p:spPr>
+          <a:xfrm>
+            <a:off x="640080" y="3291840"/>
+            <a:ext cx="2331720" cy="2286000"/>
+          </a:xfrm>
+          <a:prstGeom prst="rect">
+            <a:avLst/>
+          </a:prstGeom>
+          <a:noFill/>
+        </p:spPr>
+        <p:txBody>
+          <a:bodyPr wrap="square"/>
+          <a:lstStyle/>
+          <a:p>
+            <a:pPr algn="ctr">
+              <a:spcBef>
+                <a:spcPts val="200"/>
+              </a:spcBef>
+              <a:spcAft>
+                <a:spcPts val="200"/>
+              </a:spcAft>
+              <a:defRPr sz="1500" b="0" i="0">
+                <a:solidFill>
+                  <a:srgbClr val="B0B0B0"/>
+                </a:solidFill>
+                <a:latin typeface="Inter"/>
+              </a:defRPr>
+            </a:pPr>
+            <a:r>
+              <a:t>3-5 min/post (humain)</a:t>
+            </a:r>
+          </a:p>
+          <a:p>
+            <a:pPr algn="ctr">
+              <a:spcBef>
+                <a:spcPts val="200"/>
+              </a:spcBef>
+              <a:spcAft>
+                <a:spcPts val="200"/>
+              </a:spcAft>
+              <a:defRPr sz="1500" b="0" i="0">
+                <a:solidFill>
+                  <a:srgbClr val="B0B0B0"/>
+                </a:solidFill>
+                <a:latin typeface="Inter"/>
+              </a:defRPr>
+            </a:pPr>
+            <a:r>
+              <a:t>1,5 ms + 30s validation</a:t>
+            </a:r>
+          </a:p>
+          <a:p>
+            <a:pPr algn="ctr">
+              <a:spcBef>
+                <a:spcPts val="200"/>
+              </a:spcBef>
+              <a:spcAft>
+                <a:spcPts val="200"/>
+              </a:spcAft>
+              <a:defRPr sz="1500" b="0" i="0">
+                <a:solidFill>
+                  <a:srgbClr val="B0B0B0"/>
+                </a:solidFill>
+                <a:latin typeface="Inter"/>
+              </a:defRPr>
+            </a:pPr>
+            <a:r>
+              <a:t>= x10 productivité</a:t>
+            </a:r>
+          </a:p>
+        </p:txBody>
+      </p:sp>
+      <p:sp>
+        <p:nvSpPr>
+          <p:cNvPr id="8" name="Rounded Rectangle 7"/>
           <p:cNvSpPr/>
           <p:nvPr/>
         </p:nvSpPr>
         <p:spPr>
           <a:xfrm>
-            <a:off x="731520" y="5120640"/>
-            <a:ext cx="2926080" cy="12700"/>
-          </a:xfrm>
-          <a:prstGeom prst="rect">
-            <a:avLst/>
-          </a:prstGeom>
-          <a:solidFill>
-            <a:srgbClr val="2A2F3E"/>
-          </a:solidFill>
-          <a:ln>
-            <a:noFill/>
-          </a:ln>
-        </p:spPr>
-        <p:style>
-          <a:lnRef idx="1">
-            <a:schemeClr val="accent1"/>
-          </a:lnRef>
-          <a:fillRef idx="3">
-            <a:schemeClr val="accent1"/>
-          </a:fillRef>
-          <a:effectRef idx="2">
-            <a:schemeClr val="accent1"/>
-          </a:effectRef>
-          <a:fontRef idx="minor">
-            <a:schemeClr val="lt1"/>
-          </a:fontRef>
-        </p:style>
-        <p:txBody>
-          <a:bodyPr rtlCol="0" anchor="ctr"/>
-          <a:lstStyle/>
-          <a:p>
-            <a:pPr algn="ctr"/>
-          </a:p>
-        </p:txBody>
-      </p:sp>
-      <p:sp>
-        <p:nvSpPr>
-          <p:cNvPr id="12" name="TextBox 11"/>
-          <p:cNvSpPr txBox="1"/>
-          <p:nvPr/>
-        </p:nvSpPr>
-        <p:spPr>
-          <a:xfrm>
-            <a:off x="548640" y="5257800"/>
-            <a:ext cx="3291840" cy="365760"/>
-          </a:xfrm>
-          <a:prstGeom prst="rect">
-            <a:avLst/>
-          </a:prstGeom>
-          <a:noFill/>
-        </p:spPr>
-        <p:txBody>
-          <a:bodyPr wrap="square"/>
-          <a:lstStyle/>
-          <a:p>
-            <a:pPr algn="ctr">
-              <a:spcBef>
-                <a:spcPts val="200"/>
-              </a:spcBef>
-              <a:spcAft>
-                <a:spcPts val="200"/>
-              </a:spcAft>
-              <a:defRPr sz="1600" b="1" i="1">
-                <a:solidFill>
-                  <a:srgbClr val="FFD600"/>
-                </a:solidFill>
-                <a:latin typeface="Inter"/>
-              </a:defRPr>
-            </a:pPr>
-            <a:r>
-              <a:t>Industrialisation</a:t>
-            </a:r>
-          </a:p>
-        </p:txBody>
-      </p:sp>
-      <p:sp>
-        <p:nvSpPr>
-          <p:cNvPr id="13" name="Rounded Rectangle 12"/>
-          <p:cNvSpPr/>
-          <p:nvPr/>
-        </p:nvSpPr>
-        <p:spPr>
-          <a:xfrm>
-            <a:off x="4297680" y="1371600"/>
-            <a:ext cx="3474720" cy="4754880"/>
+            <a:off x="3337560" y="1371600"/>
+            <a:ext cx="2697480" cy="4389120"/>
           </a:xfrm>
           <a:prstGeom prst="roundRect">
             <a:avLst>
@@ -11740,14 +11727,14 @@
       </p:sp>
       <p:sp>
         <p:nvSpPr>
-          <p:cNvPr id="14" name="TextBox 13"/>
-          <p:cNvSpPr txBox="1"/>
-          <p:nvPr/>
-        </p:nvSpPr>
-        <p:spPr>
-          <a:xfrm>
-            <a:off x="4389120" y="1554480"/>
-            <a:ext cx="3291840" cy="548640"/>
+          <p:cNvPr id="9" name="TextBox 8"/>
+          <p:cNvSpPr txBox="1"/>
+          <p:nvPr/>
+        </p:nvSpPr>
+        <p:spPr>
+          <a:xfrm>
+            <a:off x="3429000" y="1554480"/>
+            <a:ext cx="2514600" cy="320040"/>
           </a:xfrm>
           <a:prstGeom prst="rect">
             <a:avLst/>
@@ -11765,7 +11752,7 @@
               <a:spcAft>
                 <a:spcPts val="200"/>
               </a:spcAft>
-              <a:defRPr sz="4000" b="1" i="0">
+              <a:defRPr sz="1600" b="1" i="0">
                 <a:solidFill>
                   <a:srgbClr val="00E676"/>
                 </a:solidFill>
@@ -11773,61 +11760,21 @@
               </a:defRPr>
             </a:pPr>
             <a:r>
-              <a:t>V11</a:t>
-            </a:r>
-          </a:p>
-        </p:txBody>
-      </p:sp>
-      <p:sp>
-        <p:nvSpPr>
-          <p:cNvPr id="15" name="TextBox 14"/>
-          <p:cNvSpPr txBox="1"/>
-          <p:nvPr/>
-        </p:nvSpPr>
-        <p:spPr>
-          <a:xfrm>
-            <a:off x="4389120" y="2148840"/>
-            <a:ext cx="3291840" cy="320040"/>
-          </a:xfrm>
-          <a:prstGeom prst="rect">
-            <a:avLst/>
-          </a:prstGeom>
-          <a:noFill/>
-        </p:spPr>
-        <p:txBody>
-          <a:bodyPr wrap="square"/>
-          <a:lstStyle/>
-          <a:p>
-            <a:pPr algn="ctr">
-              <a:spcBef>
-                <a:spcPts val="200"/>
-              </a:spcBef>
-              <a:spcAft>
-                <a:spcPts val="200"/>
-              </a:spcAft>
-              <a:defRPr sz="2000" b="0" i="0">
-                <a:solidFill>
-                  <a:srgbClr val="B0B0B0"/>
-                </a:solidFill>
-                <a:latin typeface="Inter"/>
-              </a:defRPr>
-            </a:pPr>
-            <a:r>
-              <a:t>Q4 2026</a:t>
-            </a:r>
-          </a:p>
-        </p:txBody>
-      </p:sp>
-      <p:sp>
-        <p:nvSpPr>
-          <p:cNvPr id="16" name="Rectangle 15"/>
+              <a:t>VOLUME</a:t>
+            </a:r>
+          </a:p>
+        </p:txBody>
+      </p:sp>
+      <p:sp>
+        <p:nvSpPr>
+          <p:cNvPr id="10" name="Rectangle 9"/>
           <p:cNvSpPr/>
           <p:nvPr/>
         </p:nvSpPr>
         <p:spPr>
           <a:xfrm>
-            <a:off x="4572000" y="2606040"/>
-            <a:ext cx="2926080" cy="12700"/>
+            <a:off x="3611879" y="1965960"/>
+            <a:ext cx="2148840" cy="12700"/>
           </a:xfrm>
           <a:prstGeom prst="rect">
             <a:avLst/>
@@ -11863,217 +11810,132 @@
       </p:sp>
       <p:sp>
         <p:nvSpPr>
-          <p:cNvPr id="17" name="TextBox 16"/>
-          <p:cNvSpPr txBox="1"/>
-          <p:nvPr/>
-        </p:nvSpPr>
-        <p:spPr>
-          <a:xfrm>
-            <a:off x="4663440" y="2834640"/>
-            <a:ext cx="2926080" cy="457200"/>
-          </a:xfrm>
-          <a:prstGeom prst="rect">
-            <a:avLst/>
-          </a:prstGeom>
-          <a:noFill/>
-        </p:spPr>
-        <p:txBody>
-          <a:bodyPr wrap="square"/>
-          <a:lstStyle/>
-          <a:p>
-            <a:pPr algn="l">
-              <a:spcBef>
-                <a:spcPts val="200"/>
-              </a:spcBef>
-              <a:spcAft>
-                <a:spcPts val="200"/>
-              </a:spcAft>
-              <a:defRPr sz="1700" b="0" i="0">
-                <a:solidFill>
-                  <a:srgbClr val="E8E8E8"/>
-                </a:solidFill>
-                <a:latin typeface="Inter"/>
-              </a:defRPr>
-            </a:pPr>
-            <a:r>
-              <a:t>•  ClaimBuster intégration</a:t>
-            </a:r>
-          </a:p>
-        </p:txBody>
-      </p:sp>
-      <p:sp>
-        <p:nvSpPr>
-          <p:cNvPr id="18" name="TextBox 17"/>
-          <p:cNvSpPr txBox="1"/>
-          <p:nvPr/>
-        </p:nvSpPr>
-        <p:spPr>
-          <a:xfrm>
-            <a:off x="4663440" y="3383280"/>
-            <a:ext cx="2926080" cy="457200"/>
-          </a:xfrm>
-          <a:prstGeom prst="rect">
-            <a:avLst/>
-          </a:prstGeom>
-          <a:noFill/>
-        </p:spPr>
-        <p:txBody>
-          <a:bodyPr wrap="square"/>
-          <a:lstStyle/>
-          <a:p>
-            <a:pPr algn="l">
-              <a:spcBef>
-                <a:spcPts val="200"/>
-              </a:spcBef>
-              <a:spcAft>
-                <a:spcPts val="200"/>
-              </a:spcAft>
-              <a:defRPr sz="1700" b="0" i="0">
-                <a:solidFill>
-                  <a:srgbClr val="E8E8E8"/>
-                </a:solidFill>
-                <a:latin typeface="Inter"/>
-              </a:defRPr>
-            </a:pPr>
-            <a:r>
-              <a:t>•  Monitoring Grafana</a:t>
-            </a:r>
-          </a:p>
-        </p:txBody>
-      </p:sp>
-      <p:sp>
-        <p:nvSpPr>
-          <p:cNvPr id="19" name="TextBox 18"/>
-          <p:cNvSpPr txBox="1"/>
-          <p:nvPr/>
-        </p:nvSpPr>
-        <p:spPr>
-          <a:xfrm>
-            <a:off x="4663440" y="3931920"/>
-            <a:ext cx="2926080" cy="457200"/>
-          </a:xfrm>
-          <a:prstGeom prst="rect">
-            <a:avLst/>
-          </a:prstGeom>
-          <a:noFill/>
-        </p:spPr>
-        <p:txBody>
-          <a:bodyPr wrap="square"/>
-          <a:lstStyle/>
-          <a:p>
-            <a:pPr algn="l">
-              <a:spcBef>
-                <a:spcPts val="200"/>
-              </a:spcBef>
-              <a:spcAft>
-                <a:spcPts val="200"/>
-              </a:spcAft>
-              <a:defRPr sz="1700" b="0" i="0">
-                <a:solidFill>
-                  <a:srgbClr val="E8E8E8"/>
-                </a:solidFill>
-                <a:latin typeface="Inter"/>
-              </a:defRPr>
-            </a:pPr>
-            <a:r>
-              <a:t>•  Tests E2E nightly</a:t>
-            </a:r>
-          </a:p>
-        </p:txBody>
-      </p:sp>
-      <p:sp>
-        <p:nvSpPr>
-          <p:cNvPr id="20" name="Rectangle 19"/>
+          <p:cNvPr id="11" name="TextBox 10"/>
+          <p:cNvSpPr txBox="1"/>
+          <p:nvPr/>
+        </p:nvSpPr>
+        <p:spPr>
+          <a:xfrm>
+            <a:off x="3429000" y="2103120"/>
+            <a:ext cx="2514600" cy="1097280"/>
+          </a:xfrm>
+          <a:prstGeom prst="rect">
+            <a:avLst/>
+          </a:prstGeom>
+          <a:noFill/>
+        </p:spPr>
+        <p:txBody>
+          <a:bodyPr wrap="square"/>
+          <a:lstStyle/>
+          <a:p>
+            <a:pPr algn="ctr">
+              <a:spcBef>
+                <a:spcPts val="200"/>
+              </a:spcBef>
+              <a:spcAft>
+                <a:spcPts val="200"/>
+              </a:spcAft>
+              <a:defRPr sz="5600" b="1" i="0">
+                <a:solidFill>
+                  <a:srgbClr val="00E676"/>
+                </a:solidFill>
+                <a:latin typeface="Inter"/>
+              </a:defRPr>
+            </a:pPr>
+            <a:r>
+              <a:t>200x</a:t>
+            </a:r>
+          </a:p>
+        </p:txBody>
+      </p:sp>
+      <p:sp>
+        <p:nvSpPr>
+          <p:cNvPr id="12" name="TextBox 11"/>
+          <p:cNvSpPr txBox="1"/>
+          <p:nvPr/>
+        </p:nvSpPr>
+        <p:spPr>
+          <a:xfrm>
+            <a:off x="3520440" y="3291840"/>
+            <a:ext cx="2331720" cy="2286000"/>
+          </a:xfrm>
+          <a:prstGeom prst="rect">
+            <a:avLst/>
+          </a:prstGeom>
+          <a:noFill/>
+        </p:spPr>
+        <p:txBody>
+          <a:bodyPr wrap="square"/>
+          <a:lstStyle/>
+          <a:p>
+            <a:pPr algn="ctr">
+              <a:spcBef>
+                <a:spcPts val="200"/>
+              </a:spcBef>
+              <a:spcAft>
+                <a:spcPts val="200"/>
+              </a:spcAft>
+              <a:defRPr sz="1500" b="0" i="0">
+                <a:solidFill>
+                  <a:srgbClr val="B0B0B0"/>
+                </a:solidFill>
+                <a:latin typeface="Inter"/>
+              </a:defRPr>
+            </a:pPr>
+            <a:r>
+              <a:t>60 000 posts/jour traités</a:t>
+            </a:r>
+          </a:p>
+          <a:p>
+            <a:pPr algn="ctr">
+              <a:spcBef>
+                <a:spcPts val="200"/>
+              </a:spcBef>
+              <a:spcAft>
+                <a:spcPts val="200"/>
+              </a:spcAft>
+              <a:defRPr sz="1500" b="0" i="0">
+                <a:solidFill>
+                  <a:srgbClr val="B0B0B0"/>
+                </a:solidFill>
+                <a:latin typeface="Inter"/>
+              </a:defRPr>
+            </a:pPr>
+            <a:r>
+              <a:t>vs 200-300/jour (humain)</a:t>
+            </a:r>
+          </a:p>
+          <a:p>
+            <a:pPr algn="ctr">
+              <a:spcBef>
+                <a:spcPts val="200"/>
+              </a:spcBef>
+              <a:spcAft>
+                <a:spcPts val="200"/>
+              </a:spcAft>
+              <a:defRPr sz="1500" b="0" i="0">
+                <a:solidFill>
+                  <a:srgbClr val="B0B0B0"/>
+                </a:solidFill>
+                <a:latin typeface="Inter"/>
+              </a:defRPr>
+            </a:pPr>
+            <a:r>
+              <a:t>= couverture totale</a:t>
+            </a:r>
+          </a:p>
+        </p:txBody>
+      </p:sp>
+      <p:sp>
+        <p:nvSpPr>
+          <p:cNvPr id="13" name="Rounded Rectangle 12"/>
           <p:cNvSpPr/>
           <p:nvPr/>
         </p:nvSpPr>
         <p:spPr>
           <a:xfrm>
-            <a:off x="4572000" y="5120640"/>
-            <a:ext cx="2926080" cy="12700"/>
-          </a:xfrm>
-          <a:prstGeom prst="rect">
-            <a:avLst/>
-          </a:prstGeom>
-          <a:solidFill>
-            <a:srgbClr val="2A2F3E"/>
-          </a:solidFill>
-          <a:ln>
-            <a:noFill/>
-          </a:ln>
-        </p:spPr>
-        <p:style>
-          <a:lnRef idx="1">
-            <a:schemeClr val="accent1"/>
-          </a:lnRef>
-          <a:fillRef idx="3">
-            <a:schemeClr val="accent1"/>
-          </a:fillRef>
-          <a:effectRef idx="2">
-            <a:schemeClr val="accent1"/>
-          </a:effectRef>
-          <a:fontRef idx="minor">
-            <a:schemeClr val="lt1"/>
-          </a:fontRef>
-        </p:style>
-        <p:txBody>
-          <a:bodyPr rtlCol="0" anchor="ctr"/>
-          <a:lstStyle/>
-          <a:p>
-            <a:pPr algn="ctr"/>
-          </a:p>
-        </p:txBody>
-      </p:sp>
-      <p:sp>
-        <p:nvSpPr>
-          <p:cNvPr id="21" name="TextBox 20"/>
-          <p:cNvSpPr txBox="1"/>
-          <p:nvPr/>
-        </p:nvSpPr>
-        <p:spPr>
-          <a:xfrm>
-            <a:off x="4389120" y="5257800"/>
-            <a:ext cx="3291840" cy="365760"/>
-          </a:xfrm>
-          <a:prstGeom prst="rect">
-            <a:avLst/>
-          </a:prstGeom>
-          <a:noFill/>
-        </p:spPr>
-        <p:txBody>
-          <a:bodyPr wrap="square"/>
-          <a:lstStyle/>
-          <a:p>
-            <a:pPr algn="ctr">
-              <a:spcBef>
-                <a:spcPts val="200"/>
-              </a:spcBef>
-              <a:spcAft>
-                <a:spcPts val="200"/>
-              </a:spcAft>
-              <a:defRPr sz="1600" b="1" i="1">
-                <a:solidFill>
-                  <a:srgbClr val="FFD600"/>
-                </a:solidFill>
-                <a:latin typeface="Inter"/>
-              </a:defRPr>
-            </a:pPr>
-            <a:r>
-              <a:t>Vérif. factuelle</a:t>
-            </a:r>
-          </a:p>
-        </p:txBody>
-      </p:sp>
-      <p:sp>
-        <p:nvSpPr>
-          <p:cNvPr id="22" name="Rounded Rectangle 21"/>
-          <p:cNvSpPr/>
-          <p:nvPr/>
-        </p:nvSpPr>
-        <p:spPr>
-          <a:xfrm>
-            <a:off x="8138160" y="1371600"/>
-            <a:ext cx="3474720" cy="4754880"/>
+            <a:off x="6217920" y="1371600"/>
+            <a:ext cx="2697480" cy="4389120"/>
           </a:xfrm>
           <a:prstGeom prst="roundRect">
             <a:avLst>
@@ -12113,14 +11975,14 @@
       </p:sp>
       <p:sp>
         <p:nvSpPr>
-          <p:cNvPr id="23" name="TextBox 22"/>
-          <p:cNvSpPr txBox="1"/>
-          <p:nvPr/>
-        </p:nvSpPr>
-        <p:spPr>
-          <a:xfrm>
-            <a:off x="8229600" y="1554480"/>
-            <a:ext cx="3291840" cy="548640"/>
+          <p:cNvPr id="14" name="TextBox 13"/>
+          <p:cNvSpPr txBox="1"/>
+          <p:nvPr/>
+        </p:nvSpPr>
+        <p:spPr>
+          <a:xfrm>
+            <a:off x="6309359" y="1554480"/>
+            <a:ext cx="2514600" cy="320040"/>
           </a:xfrm>
           <a:prstGeom prst="rect">
             <a:avLst/>
@@ -12138,7 +12000,7 @@
               <a:spcAft>
                 <a:spcPts val="200"/>
               </a:spcAft>
-              <a:defRPr sz="4000" b="1" i="0">
+              <a:defRPr sz="1600" b="1" i="0">
                 <a:solidFill>
                   <a:srgbClr val="FFD600"/>
                 </a:solidFill>
@@ -12146,61 +12008,21 @@
               </a:defRPr>
             </a:pPr>
             <a:r>
-              <a:t>V12</a:t>
-            </a:r>
-          </a:p>
-        </p:txBody>
-      </p:sp>
-      <p:sp>
-        <p:nvSpPr>
-          <p:cNvPr id="24" name="TextBox 23"/>
-          <p:cNvSpPr txBox="1"/>
-          <p:nvPr/>
-        </p:nvSpPr>
-        <p:spPr>
-          <a:xfrm>
-            <a:off x="8229600" y="2148840"/>
-            <a:ext cx="3291840" cy="320040"/>
-          </a:xfrm>
-          <a:prstGeom prst="rect">
-            <a:avLst/>
-          </a:prstGeom>
-          <a:noFill/>
-        </p:spPr>
-        <p:txBody>
-          <a:bodyPr wrap="square"/>
-          <a:lstStyle/>
-          <a:p>
-            <a:pPr algn="ctr">
-              <a:spcBef>
-                <a:spcPts val="200"/>
-              </a:spcBef>
-              <a:spcAft>
-                <a:spcPts val="200"/>
-              </a:spcAft>
-              <a:defRPr sz="2000" b="0" i="0">
-                <a:solidFill>
-                  <a:srgbClr val="B0B0B0"/>
-                </a:solidFill>
-                <a:latin typeface="Inter"/>
-              </a:defRPr>
-            </a:pPr>
-            <a:r>
-              <a:t>2027</a:t>
-            </a:r>
-          </a:p>
-        </p:txBody>
-      </p:sp>
-      <p:sp>
-        <p:nvSpPr>
-          <p:cNvPr id="25" name="Rectangle 24"/>
+              <a:t>RISQUE</a:t>
+            </a:r>
+          </a:p>
+        </p:txBody>
+      </p:sp>
+      <p:sp>
+        <p:nvSpPr>
+          <p:cNvPr id="15" name="Rectangle 14"/>
           <p:cNvSpPr/>
           <p:nvPr/>
         </p:nvSpPr>
         <p:spPr>
           <a:xfrm>
-            <a:off x="8412480" y="2606040"/>
-            <a:ext cx="2926080" cy="12700"/>
+            <a:off x="6492240" y="1965960"/>
+            <a:ext cx="2148840" cy="12700"/>
           </a:xfrm>
           <a:prstGeom prst="rect">
             <a:avLst/>
@@ -12236,134 +12058,219 @@
       </p:sp>
       <p:sp>
         <p:nvSpPr>
-          <p:cNvPr id="26" name="TextBox 25"/>
-          <p:cNvSpPr txBox="1"/>
-          <p:nvPr/>
-        </p:nvSpPr>
-        <p:spPr>
-          <a:xfrm>
-            <a:off x="8503920" y="2834640"/>
-            <a:ext cx="2926080" cy="457200"/>
-          </a:xfrm>
-          <a:prstGeom prst="rect">
-            <a:avLst/>
-          </a:prstGeom>
-          <a:noFill/>
-        </p:spPr>
-        <p:txBody>
-          <a:bodyPr wrap="square"/>
-          <a:lstStyle/>
-          <a:p>
-            <a:pPr algn="l">
-              <a:spcBef>
-                <a:spcPts val="200"/>
-              </a:spcBef>
-              <a:spcAft>
-                <a:spcPts val="200"/>
-              </a:spcAft>
-              <a:defRPr sz="1700" b="0" i="0">
-                <a:solidFill>
-                  <a:srgbClr val="E8E8E8"/>
-                </a:solidFill>
-                <a:latin typeface="Inter"/>
-              </a:defRPr>
-            </a:pPr>
-            <a:r>
-              <a:t>•  Modèle FR spécialisé</a:t>
-            </a:r>
-          </a:p>
-        </p:txBody>
-      </p:sp>
-      <p:sp>
-        <p:nvSpPr>
-          <p:cNvPr id="27" name="TextBox 26"/>
-          <p:cNvSpPr txBox="1"/>
-          <p:nvPr/>
-        </p:nvSpPr>
-        <p:spPr>
-          <a:xfrm>
-            <a:off x="8503920" y="3383280"/>
-            <a:ext cx="2926080" cy="457200"/>
-          </a:xfrm>
-          <a:prstGeom prst="rect">
-            <a:avLst/>
-          </a:prstGeom>
-          <a:noFill/>
-        </p:spPr>
-        <p:txBody>
-          <a:bodyPr wrap="square"/>
-          <a:lstStyle/>
-          <a:p>
-            <a:pPr algn="l">
-              <a:spcBef>
-                <a:spcPts val="200"/>
-              </a:spcBef>
-              <a:spcAft>
-                <a:spcPts val="200"/>
-              </a:spcAft>
-              <a:defRPr sz="1700" b="0" i="0">
-                <a:solidFill>
-                  <a:srgbClr val="E8E8E8"/>
-                </a:solidFill>
-                <a:latin typeface="Inter"/>
-              </a:defRPr>
-            </a:pPr>
-            <a:r>
-              <a:t>•  Annotation communautaire</a:t>
-            </a:r>
-          </a:p>
-        </p:txBody>
-      </p:sp>
-      <p:sp>
-        <p:nvSpPr>
-          <p:cNvPr id="28" name="TextBox 27"/>
-          <p:cNvSpPr txBox="1"/>
-          <p:nvPr/>
-        </p:nvSpPr>
-        <p:spPr>
-          <a:xfrm>
-            <a:off x="8503920" y="3931920"/>
-            <a:ext cx="2926080" cy="457200"/>
-          </a:xfrm>
-          <a:prstGeom prst="rect">
-            <a:avLst/>
-          </a:prstGeom>
-          <a:noFill/>
-        </p:spPr>
-        <p:txBody>
-          <a:bodyPr wrap="square"/>
-          <a:lstStyle/>
-          <a:p>
-            <a:pPr algn="l">
-              <a:spcBef>
-                <a:spcPts val="200"/>
-              </a:spcBef>
-              <a:spcAft>
-                <a:spcPts val="200"/>
-              </a:spcAft>
-              <a:defRPr sz="1700" b="0" i="0">
-                <a:solidFill>
-                  <a:srgbClr val="E8E8E8"/>
-                </a:solidFill>
-                <a:latin typeface="Inter"/>
-              </a:defRPr>
-            </a:pPr>
-            <a:r>
-              <a:t>•  Federated learning</a:t>
-            </a:r>
-          </a:p>
-        </p:txBody>
-      </p:sp>
-      <p:sp>
-        <p:nvSpPr>
-          <p:cNvPr id="29" name="Rectangle 28"/>
+          <p:cNvPr id="16" name="TextBox 15"/>
+          <p:cNvSpPr txBox="1"/>
+          <p:nvPr/>
+        </p:nvSpPr>
+        <p:spPr>
+          <a:xfrm>
+            <a:off x="6309359" y="2103120"/>
+            <a:ext cx="2514600" cy="1097280"/>
+          </a:xfrm>
+          <a:prstGeom prst="rect">
+            <a:avLst/>
+          </a:prstGeom>
+          <a:noFill/>
+        </p:spPr>
+        <p:txBody>
+          <a:bodyPr wrap="square"/>
+          <a:lstStyle/>
+          <a:p>
+            <a:pPr algn="ctr">
+              <a:spcBef>
+                <a:spcPts val="200"/>
+              </a:spcBef>
+              <a:spcAft>
+                <a:spcPts val="200"/>
+              </a:spcAft>
+              <a:defRPr sz="5600" b="1" i="0">
+                <a:solidFill>
+                  <a:srgbClr val="FFD600"/>
+                </a:solidFill>
+                <a:latin typeface="Inter"/>
+              </a:defRPr>
+            </a:pPr>
+            <a:r>
+              <a:t>-67%</a:t>
+            </a:r>
+          </a:p>
+        </p:txBody>
+      </p:sp>
+      <p:sp>
+        <p:nvSpPr>
+          <p:cNvPr id="17" name="TextBox 16"/>
+          <p:cNvSpPr txBox="1"/>
+          <p:nvPr/>
+        </p:nvSpPr>
+        <p:spPr>
+          <a:xfrm>
+            <a:off x="6400800" y="3291840"/>
+            <a:ext cx="2331720" cy="2286000"/>
+          </a:xfrm>
+          <a:prstGeom prst="rect">
+            <a:avLst/>
+          </a:prstGeom>
+          <a:noFill/>
+        </p:spPr>
+        <p:txBody>
+          <a:bodyPr wrap="square"/>
+          <a:lstStyle/>
+          <a:p>
+            <a:pPr algn="ctr">
+              <a:spcBef>
+                <a:spcPts val="200"/>
+              </a:spcBef>
+              <a:spcAft>
+                <a:spcPts val="200"/>
+              </a:spcAft>
+              <a:defRPr sz="1500" b="0" i="0">
+                <a:solidFill>
+                  <a:srgbClr val="B0B0B0"/>
+                </a:solidFill>
+                <a:latin typeface="Inter"/>
+              </a:defRPr>
+            </a:pPr>
+            <a:r>
+              <a:t>AI Act + RGPD intégrés</a:t>
+            </a:r>
+          </a:p>
+          <a:p>
+            <a:pPr algn="ctr">
+              <a:spcBef>
+                <a:spcPts val="200"/>
+              </a:spcBef>
+              <a:spcAft>
+                <a:spcPts val="200"/>
+              </a:spcAft>
+              <a:defRPr sz="1500" b="0" i="0">
+                <a:solidFill>
+                  <a:srgbClr val="B0B0B0"/>
+                </a:solidFill>
+                <a:latin typeface="Inter"/>
+              </a:defRPr>
+            </a:pPr>
+            <a:r>
+              <a:t>FP réduits de 67 %</a:t>
+            </a:r>
+          </a:p>
+          <a:p>
+            <a:pPr algn="ctr">
+              <a:spcBef>
+                <a:spcPts val="200"/>
+              </a:spcBef>
+              <a:spcAft>
+                <a:spcPts val="200"/>
+              </a:spcAft>
+              <a:defRPr sz="1500" b="0" i="0">
+                <a:solidFill>
+                  <a:srgbClr val="B0B0B0"/>
+                </a:solidFill>
+                <a:latin typeface="Inter"/>
+              </a:defRPr>
+            </a:pPr>
+            <a:r>
+              <a:t>= confiance préservée</a:t>
+            </a:r>
+          </a:p>
+        </p:txBody>
+      </p:sp>
+      <p:sp>
+        <p:nvSpPr>
+          <p:cNvPr id="18" name="Rounded Rectangle 17"/>
           <p:cNvSpPr/>
           <p:nvPr/>
         </p:nvSpPr>
         <p:spPr>
           <a:xfrm>
-            <a:off x="8412480" y="5120640"/>
-            <a:ext cx="2926080" cy="12700"/>
+            <a:off x="9098280" y="1371600"/>
+            <a:ext cx="2697480" cy="4389120"/>
+          </a:xfrm>
+          <a:prstGeom prst="roundRect">
+            <a:avLst>
+              <a:gd name="adj" fmla="val 15000"/>
+            </a:avLst>
+          </a:prstGeom>
+          <a:solidFill>
+            <a:srgbClr val="1A1F2E"/>
+          </a:solidFill>
+          <a:ln w="19050">
+            <a:solidFill>
+              <a:srgbClr val="FF1744"/>
+            </a:solidFill>
+          </a:ln>
+        </p:spPr>
+        <p:style>
+          <a:lnRef idx="1">
+            <a:schemeClr val="accent1"/>
+          </a:lnRef>
+          <a:fillRef idx="3">
+            <a:schemeClr val="accent1"/>
+          </a:fillRef>
+          <a:effectRef idx="2">
+            <a:schemeClr val="accent1"/>
+          </a:effectRef>
+          <a:fontRef idx="minor">
+            <a:schemeClr val="lt1"/>
+          </a:fontRef>
+        </p:style>
+        <p:txBody>
+          <a:bodyPr rtlCol="0" anchor="ctr"/>
+          <a:lstStyle/>
+          <a:p>
+            <a:pPr algn="ctr"/>
+          </a:p>
+        </p:txBody>
+      </p:sp>
+      <p:sp>
+        <p:nvSpPr>
+          <p:cNvPr id="19" name="TextBox 18"/>
+          <p:cNvSpPr txBox="1"/>
+          <p:nvPr/>
+        </p:nvSpPr>
+        <p:spPr>
+          <a:xfrm>
+            <a:off x="9189719" y="1554480"/>
+            <a:ext cx="2514600" cy="320040"/>
+          </a:xfrm>
+          <a:prstGeom prst="rect">
+            <a:avLst/>
+          </a:prstGeom>
+          <a:noFill/>
+        </p:spPr>
+        <p:txBody>
+          <a:bodyPr wrap="square"/>
+          <a:lstStyle/>
+          <a:p>
+            <a:pPr algn="ctr">
+              <a:spcBef>
+                <a:spcPts val="200"/>
+              </a:spcBef>
+              <a:spcAft>
+                <a:spcPts val="200"/>
+              </a:spcAft>
+              <a:defRPr sz="1600" b="1" i="0">
+                <a:solidFill>
+                  <a:srgbClr val="FF1744"/>
+                </a:solidFill>
+                <a:latin typeface="Inter"/>
+              </a:defRPr>
+            </a:pPr>
+            <a:r>
+              <a:t>COÛT</a:t>
+            </a:r>
+          </a:p>
+        </p:txBody>
+      </p:sp>
+      <p:sp>
+        <p:nvSpPr>
+          <p:cNvPr id="20" name="Rectangle 19"/>
+          <p:cNvSpPr/>
+          <p:nvPr/>
+        </p:nvSpPr>
+        <p:spPr>
+          <a:xfrm>
+            <a:off x="9372600" y="1965960"/>
+            <a:ext cx="2148840" cy="12700"/>
           </a:xfrm>
           <a:prstGeom prst="rect">
             <a:avLst/>
@@ -12399,14 +12306,14 @@
       </p:sp>
       <p:sp>
         <p:nvSpPr>
-          <p:cNvPr id="30" name="TextBox 29"/>
-          <p:cNvSpPr txBox="1"/>
-          <p:nvPr/>
-        </p:nvSpPr>
-        <p:spPr>
-          <a:xfrm>
-            <a:off x="8229600" y="5257800"/>
-            <a:ext cx="3291840" cy="365760"/>
+          <p:cNvPr id="21" name="TextBox 20"/>
+          <p:cNvSpPr txBox="1"/>
+          <p:nvPr/>
+        </p:nvSpPr>
+        <p:spPr>
+          <a:xfrm>
+            <a:off x="9189719" y="2103120"/>
+            <a:ext cx="2514600" cy="1097280"/>
           </a:xfrm>
           <a:prstGeom prst="rect">
             <a:avLst/>
@@ -12424,22 +12331,140 @@
               <a:spcAft>
                 <a:spcPts val="200"/>
               </a:spcAft>
-              <a:defRPr sz="1600" b="1" i="1">
-                <a:solidFill>
-                  <a:srgbClr val="FFD600"/>
-                </a:solidFill>
-                <a:latin typeface="Inter"/>
-              </a:defRPr>
-            </a:pPr>
-            <a:r>
-              <a:t>Inclusion</a:t>
-            </a:r>
-          </a:p>
-        </p:txBody>
-      </p:sp>
-      <p:sp>
-        <p:nvSpPr>
-          <p:cNvPr id="31" name="TextBox 30"/>
+              <a:defRPr sz="5600" b="1" i="0">
+                <a:solidFill>
+                  <a:srgbClr val="FF1744"/>
+                </a:solidFill>
+                <a:latin typeface="Inter"/>
+              </a:defRPr>
+            </a:pPr>
+            <a:r>
+              <a:t>≈ 0</a:t>
+            </a:r>
+          </a:p>
+        </p:txBody>
+      </p:sp>
+      <p:sp>
+        <p:nvSpPr>
+          <p:cNvPr id="22" name="TextBox 21"/>
+          <p:cNvSpPr txBox="1"/>
+          <p:nvPr/>
+        </p:nvSpPr>
+        <p:spPr>
+          <a:xfrm>
+            <a:off x="9281159" y="3291840"/>
+            <a:ext cx="2331720" cy="2286000"/>
+          </a:xfrm>
+          <a:prstGeom prst="rect">
+            <a:avLst/>
+          </a:prstGeom>
+          <a:noFill/>
+        </p:spPr>
+        <p:txBody>
+          <a:bodyPr wrap="square"/>
+          <a:lstStyle/>
+          <a:p>
+            <a:pPr algn="ctr">
+              <a:spcBef>
+                <a:spcPts val="200"/>
+              </a:spcBef>
+              <a:spcAft>
+                <a:spcPts val="200"/>
+              </a:spcAft>
+              <a:defRPr sz="1500" b="0" i="0">
+                <a:solidFill>
+                  <a:srgbClr val="B0B0B0"/>
+                </a:solidFill>
+                <a:latin typeface="Inter"/>
+              </a:defRPr>
+            </a:pPr>
+            <a:r>
+              <a:t>Machine 22W, 6,9 g CO₂</a:t>
+            </a:r>
+          </a:p>
+          <a:p>
+            <a:pPr algn="ctr">
+              <a:spcBef>
+                <a:spcPts val="200"/>
+              </a:spcBef>
+              <a:spcAft>
+                <a:spcPts val="200"/>
+              </a:spcAft>
+              <a:defRPr sz="1500" b="0" i="0">
+                <a:solidFill>
+                  <a:srgbClr val="B0B0B0"/>
+                </a:solidFill>
+                <a:latin typeface="Inter"/>
+              </a:defRPr>
+            </a:pPr>
+            <a:r>
+              <a:t>Coût marginal/post ≈ 0</a:t>
+            </a:r>
+          </a:p>
+          <a:p>
+            <a:pPr algn="ctr">
+              <a:spcBef>
+                <a:spcPts val="200"/>
+              </a:spcBef>
+              <a:spcAft>
+                <a:spcPts val="200"/>
+              </a:spcAft>
+              <a:defRPr sz="1500" b="0" i="0">
+                <a:solidFill>
+                  <a:srgbClr val="B0B0B0"/>
+                </a:solidFill>
+                <a:latin typeface="Inter"/>
+              </a:defRPr>
+            </a:pPr>
+            <a:r>
+              <a:t>Aucune GPU cloud requise</a:t>
+            </a:r>
+          </a:p>
+        </p:txBody>
+      </p:sp>
+      <p:sp>
+        <p:nvSpPr>
+          <p:cNvPr id="23" name="TextBox 22"/>
+          <p:cNvSpPr txBox="1"/>
+          <p:nvPr/>
+        </p:nvSpPr>
+        <p:spPr>
+          <a:xfrm>
+            <a:off x="457200" y="6263640"/>
+            <a:ext cx="11247120" cy="274320"/>
+          </a:xfrm>
+          <a:prstGeom prst="rect">
+            <a:avLst/>
+          </a:prstGeom>
+          <a:noFill/>
+        </p:spPr>
+        <p:txBody>
+          <a:bodyPr wrap="square"/>
+          <a:lstStyle/>
+          <a:p>
+            <a:pPr algn="ctr">
+              <a:spcBef>
+                <a:spcPts val="200"/>
+              </a:spcBef>
+              <a:spcAft>
+                <a:spcPts val="200"/>
+              </a:spcAft>
+              <a:defRPr sz="1500" b="0" i="1">
+                <a:solidFill>
+                  <a:srgbClr val="606060"/>
+                </a:solidFill>
+                <a:latin typeface="Inter"/>
+              </a:defRPr>
+            </a:pPr>
+            <a:r>
+              <a:t>Niamato Consulting — Thumalien V9 : de l'analyse à la décision en 1,5 ms</a:t>
+            </a:r>
+          </a:p>
+        </p:txBody>
+      </p:sp>
+      <p:sp>
+        <p:nvSpPr>
+          <p:cNvPr id="24" name="TextBox 23"/>
           <p:cNvSpPr txBox="1"/>
           <p:nvPr/>
         </p:nvSpPr>
@@ -12468,14 +12493,14 @@
               </a:defRPr>
             </a:pPr>
             <a:r>
-              <a:t>Thumalien V9  ·  M1 BDIA 2026</a:t>
-            </a:r>
-          </a:p>
-        </p:txBody>
-      </p:sp>
-      <p:sp>
-        <p:nvSpPr>
-          <p:cNvPr id="32" name="TextBox 31"/>
+              <a:t>Niamato Consulting  ·  Thumalien V9  ·  M1 BDIA 2026</a:t>
+            </a:r>
+          </a:p>
+        </p:txBody>
+      </p:sp>
+      <p:sp>
+        <p:nvSpPr>
+          <p:cNvPr id="25" name="TextBox 24"/>
           <p:cNvSpPr txBox="1"/>
           <p:nvPr/>
         </p:nvSpPr>
@@ -12504,7 +12529,7 @@
               </a:defRPr>
             </a:pPr>
             <a:r>
-              <a:t>14 / 16</a:t>
+              <a:t>14 / 17</a:t>
             </a:r>
           </a:p>
         </p:txBody>
@@ -12518,6 +12543,1302 @@
 </file>
 
 <file path=ppt/slides/slide15.xml><?xml version="1.0" encoding="utf-8"?>
+<p:sld xmlns:a="http://schemas.openxmlformats.org/drawingml/2006/main" xmlns:p="http://schemas.openxmlformats.org/presentationml/2006/main" xmlns:r="http://schemas.openxmlformats.org/officeDocument/2006/relationships">
+  <p:cSld>
+    <p:bg>
+      <p:bgPr>
+        <a:solidFill>
+          <a:srgbClr val="0E1117"/>
+        </a:solidFill>
+        <a:effectLst/>
+      </p:bgPr>
+    </p:bg>
+    <p:spTree>
+      <p:nvGrpSpPr>
+        <p:cNvPr id="1" name=""/>
+        <p:cNvGrpSpPr/>
+        <p:nvPr/>
+      </p:nvGrpSpPr>
+      <p:grpSpPr/>
+      <p:sp>
+        <p:nvSpPr>
+          <p:cNvPr id="2" name="TextBox 1"/>
+          <p:cNvSpPr txBox="1"/>
+          <p:nvPr/>
+        </p:nvSpPr>
+        <p:spPr>
+          <a:xfrm>
+            <a:off x="731520" y="228600"/>
+            <a:ext cx="10515600" cy="777240"/>
+          </a:xfrm>
+          <a:prstGeom prst="rect">
+            <a:avLst/>
+          </a:prstGeom>
+          <a:noFill/>
+        </p:spPr>
+        <p:txBody>
+          <a:bodyPr wrap="square">
+            <a:spAutoFit/>
+          </a:bodyPr>
+          <a:lstStyle/>
+          <a:p>
+            <a:pPr>
+              <a:spcAft>
+                <a:spcPts val="0"/>
+              </a:spcAft>
+              <a:defRPr sz="4400" b="1">
+                <a:solidFill>
+                  <a:srgbClr val="00D4FF"/>
+                </a:solidFill>
+                <a:latin typeface="Inter"/>
+              </a:defRPr>
+            </a:pPr>
+            <a:r>
+              <a:t>ROADMAP — VERS V12</a:t>
+            </a:r>
+          </a:p>
+        </p:txBody>
+      </p:sp>
+      <p:sp>
+        <p:nvSpPr>
+          <p:cNvPr id="3" name="TextBox 2"/>
+          <p:cNvSpPr txBox="1"/>
+          <p:nvPr/>
+        </p:nvSpPr>
+        <p:spPr>
+          <a:xfrm>
+            <a:off x="731520" y="868680"/>
+            <a:ext cx="10058400" cy="365760"/>
+          </a:xfrm>
+          <a:prstGeom prst="rect">
+            <a:avLst/>
+          </a:prstGeom>
+          <a:noFill/>
+        </p:spPr>
+        <p:txBody>
+          <a:bodyPr wrap="square"/>
+          <a:lstStyle/>
+          <a:p>
+            <a:pPr algn="l">
+              <a:spcBef>
+                <a:spcPts val="200"/>
+              </a:spcBef>
+              <a:spcAft>
+                <a:spcPts val="200"/>
+              </a:spcAft>
+              <a:defRPr sz="2200" b="0" i="0">
+                <a:solidFill>
+                  <a:srgbClr val="B0B0B0"/>
+                </a:solidFill>
+                <a:latin typeface="Inter"/>
+              </a:defRPr>
+            </a:pPr>
+            <a:r>
+              <a:t>Limites assumées et perspectives</a:t>
+            </a:r>
+          </a:p>
+        </p:txBody>
+      </p:sp>
+      <p:sp>
+        <p:nvSpPr>
+          <p:cNvPr id="4" name="Rounded Rectangle 3"/>
+          <p:cNvSpPr/>
+          <p:nvPr/>
+        </p:nvSpPr>
+        <p:spPr>
+          <a:xfrm>
+            <a:off x="457200" y="1371600"/>
+            <a:ext cx="3474720" cy="4754880"/>
+          </a:xfrm>
+          <a:prstGeom prst="roundRect">
+            <a:avLst>
+              <a:gd name="adj" fmla="val 15000"/>
+            </a:avLst>
+          </a:prstGeom>
+          <a:solidFill>
+            <a:srgbClr val="1A1F2E"/>
+          </a:solidFill>
+          <a:ln w="19050">
+            <a:solidFill>
+              <a:srgbClr val="00D4FF"/>
+            </a:solidFill>
+          </a:ln>
+        </p:spPr>
+        <p:style>
+          <a:lnRef idx="1">
+            <a:schemeClr val="accent1"/>
+          </a:lnRef>
+          <a:fillRef idx="3">
+            <a:schemeClr val="accent1"/>
+          </a:fillRef>
+          <a:effectRef idx="2">
+            <a:schemeClr val="accent1"/>
+          </a:effectRef>
+          <a:fontRef idx="minor">
+            <a:schemeClr val="lt1"/>
+          </a:fontRef>
+        </p:style>
+        <p:txBody>
+          <a:bodyPr rtlCol="0" anchor="ctr"/>
+          <a:lstStyle/>
+          <a:p>
+            <a:pPr algn="ctr"/>
+          </a:p>
+        </p:txBody>
+      </p:sp>
+      <p:sp>
+        <p:nvSpPr>
+          <p:cNvPr id="5" name="TextBox 4"/>
+          <p:cNvSpPr txBox="1"/>
+          <p:nvPr/>
+        </p:nvSpPr>
+        <p:spPr>
+          <a:xfrm>
+            <a:off x="548640" y="1554480"/>
+            <a:ext cx="3291840" cy="548640"/>
+          </a:xfrm>
+          <a:prstGeom prst="rect">
+            <a:avLst/>
+          </a:prstGeom>
+          <a:noFill/>
+        </p:spPr>
+        <p:txBody>
+          <a:bodyPr wrap="square"/>
+          <a:lstStyle/>
+          <a:p>
+            <a:pPr algn="ctr">
+              <a:spcBef>
+                <a:spcPts val="200"/>
+              </a:spcBef>
+              <a:spcAft>
+                <a:spcPts val="200"/>
+              </a:spcAft>
+              <a:defRPr sz="4000" b="1" i="0">
+                <a:solidFill>
+                  <a:srgbClr val="00D4FF"/>
+                </a:solidFill>
+                <a:latin typeface="Inter"/>
+              </a:defRPr>
+            </a:pPr>
+            <a:r>
+              <a:t>V10</a:t>
+            </a:r>
+          </a:p>
+        </p:txBody>
+      </p:sp>
+      <p:sp>
+        <p:nvSpPr>
+          <p:cNvPr id="6" name="TextBox 5"/>
+          <p:cNvSpPr txBox="1"/>
+          <p:nvPr/>
+        </p:nvSpPr>
+        <p:spPr>
+          <a:xfrm>
+            <a:off x="548640" y="2148840"/>
+            <a:ext cx="3291840" cy="320040"/>
+          </a:xfrm>
+          <a:prstGeom prst="rect">
+            <a:avLst/>
+          </a:prstGeom>
+          <a:noFill/>
+        </p:spPr>
+        <p:txBody>
+          <a:bodyPr wrap="square"/>
+          <a:lstStyle/>
+          <a:p>
+            <a:pPr algn="ctr">
+              <a:spcBef>
+                <a:spcPts val="200"/>
+              </a:spcBef>
+              <a:spcAft>
+                <a:spcPts val="200"/>
+              </a:spcAft>
+              <a:defRPr sz="2000" b="0" i="0">
+                <a:solidFill>
+                  <a:srgbClr val="B0B0B0"/>
+                </a:solidFill>
+                <a:latin typeface="Inter"/>
+              </a:defRPr>
+            </a:pPr>
+            <a:r>
+              <a:t>Q3 2026</a:t>
+            </a:r>
+          </a:p>
+        </p:txBody>
+      </p:sp>
+      <p:sp>
+        <p:nvSpPr>
+          <p:cNvPr id="7" name="Rectangle 6"/>
+          <p:cNvSpPr/>
+          <p:nvPr/>
+        </p:nvSpPr>
+        <p:spPr>
+          <a:xfrm>
+            <a:off x="731520" y="2606040"/>
+            <a:ext cx="2926080" cy="12700"/>
+          </a:xfrm>
+          <a:prstGeom prst="rect">
+            <a:avLst/>
+          </a:prstGeom>
+          <a:solidFill>
+            <a:srgbClr val="2A2F3E"/>
+          </a:solidFill>
+          <a:ln>
+            <a:noFill/>
+          </a:ln>
+        </p:spPr>
+        <p:style>
+          <a:lnRef idx="1">
+            <a:schemeClr val="accent1"/>
+          </a:lnRef>
+          <a:fillRef idx="3">
+            <a:schemeClr val="accent1"/>
+          </a:fillRef>
+          <a:effectRef idx="2">
+            <a:schemeClr val="accent1"/>
+          </a:effectRef>
+          <a:fontRef idx="minor">
+            <a:schemeClr val="lt1"/>
+          </a:fontRef>
+        </p:style>
+        <p:txBody>
+          <a:bodyPr rtlCol="0" anchor="ctr"/>
+          <a:lstStyle/>
+          <a:p>
+            <a:pPr algn="ctr"/>
+          </a:p>
+        </p:txBody>
+      </p:sp>
+      <p:sp>
+        <p:nvSpPr>
+          <p:cNvPr id="8" name="TextBox 7"/>
+          <p:cNvSpPr txBox="1"/>
+          <p:nvPr/>
+        </p:nvSpPr>
+        <p:spPr>
+          <a:xfrm>
+            <a:off x="822960" y="2834640"/>
+            <a:ext cx="2926080" cy="457200"/>
+          </a:xfrm>
+          <a:prstGeom prst="rect">
+            <a:avLst/>
+          </a:prstGeom>
+          <a:noFill/>
+        </p:spPr>
+        <p:txBody>
+          <a:bodyPr wrap="square"/>
+          <a:lstStyle/>
+          <a:p>
+            <a:pPr algn="l">
+              <a:spcBef>
+                <a:spcPts val="200"/>
+              </a:spcBef>
+              <a:spcAft>
+                <a:spcPts val="200"/>
+              </a:spcAft>
+              <a:defRPr sz="1700" b="0" i="0">
+                <a:solidFill>
+                  <a:srgbClr val="E8E8E8"/>
+                </a:solidFill>
+                <a:latin typeface="Inter"/>
+              </a:defRPr>
+            </a:pPr>
+            <a:r>
+              <a:t>•  MLflow tracking</a:t>
+            </a:r>
+          </a:p>
+        </p:txBody>
+      </p:sp>
+      <p:sp>
+        <p:nvSpPr>
+          <p:cNvPr id="9" name="TextBox 8"/>
+          <p:cNvSpPr txBox="1"/>
+          <p:nvPr/>
+        </p:nvSpPr>
+        <p:spPr>
+          <a:xfrm>
+            <a:off x="822960" y="3383280"/>
+            <a:ext cx="2926080" cy="457200"/>
+          </a:xfrm>
+          <a:prstGeom prst="rect">
+            <a:avLst/>
+          </a:prstGeom>
+          <a:noFill/>
+        </p:spPr>
+        <p:txBody>
+          <a:bodyPr wrap="square"/>
+          <a:lstStyle/>
+          <a:p>
+            <a:pPr algn="l">
+              <a:spcBef>
+                <a:spcPts val="200"/>
+              </a:spcBef>
+              <a:spcAft>
+                <a:spcPts val="200"/>
+              </a:spcAft>
+              <a:defRPr sz="1700" b="0" i="0">
+                <a:solidFill>
+                  <a:srgbClr val="E8E8E8"/>
+                </a:solidFill>
+                <a:latin typeface="Inter"/>
+              </a:defRPr>
+            </a:pPr>
+            <a:r>
+              <a:t>•  Drift monitoring</a:t>
+            </a:r>
+          </a:p>
+        </p:txBody>
+      </p:sp>
+      <p:sp>
+        <p:nvSpPr>
+          <p:cNvPr id="10" name="TextBox 9"/>
+          <p:cNvSpPr txBox="1"/>
+          <p:nvPr/>
+        </p:nvSpPr>
+        <p:spPr>
+          <a:xfrm>
+            <a:off x="822960" y="3931920"/>
+            <a:ext cx="2926080" cy="457200"/>
+          </a:xfrm>
+          <a:prstGeom prst="rect">
+            <a:avLst/>
+          </a:prstGeom>
+          <a:noFill/>
+        </p:spPr>
+        <p:txBody>
+          <a:bodyPr wrap="square"/>
+          <a:lstStyle/>
+          <a:p>
+            <a:pPr algn="l">
+              <a:spcBef>
+                <a:spcPts val="200"/>
+              </a:spcBef>
+              <a:spcAft>
+                <a:spcPts val="200"/>
+              </a:spcAft>
+              <a:defRPr sz="1700" b="0" i="0">
+                <a:solidFill>
+                  <a:srgbClr val="E8E8E8"/>
+                </a:solidFill>
+                <a:latin typeface="Inter"/>
+              </a:defRPr>
+            </a:pPr>
+            <a:r>
+              <a:t>•  Streamlit AppTest</a:t>
+            </a:r>
+          </a:p>
+        </p:txBody>
+      </p:sp>
+      <p:sp>
+        <p:nvSpPr>
+          <p:cNvPr id="11" name="Rectangle 10"/>
+          <p:cNvSpPr/>
+          <p:nvPr/>
+        </p:nvSpPr>
+        <p:spPr>
+          <a:xfrm>
+            <a:off x="731520" y="5120640"/>
+            <a:ext cx="2926080" cy="12700"/>
+          </a:xfrm>
+          <a:prstGeom prst="rect">
+            <a:avLst/>
+          </a:prstGeom>
+          <a:solidFill>
+            <a:srgbClr val="2A2F3E"/>
+          </a:solidFill>
+          <a:ln>
+            <a:noFill/>
+          </a:ln>
+        </p:spPr>
+        <p:style>
+          <a:lnRef idx="1">
+            <a:schemeClr val="accent1"/>
+          </a:lnRef>
+          <a:fillRef idx="3">
+            <a:schemeClr val="accent1"/>
+          </a:fillRef>
+          <a:effectRef idx="2">
+            <a:schemeClr val="accent1"/>
+          </a:effectRef>
+          <a:fontRef idx="minor">
+            <a:schemeClr val="lt1"/>
+          </a:fontRef>
+        </p:style>
+        <p:txBody>
+          <a:bodyPr rtlCol="0" anchor="ctr"/>
+          <a:lstStyle/>
+          <a:p>
+            <a:pPr algn="ctr"/>
+          </a:p>
+        </p:txBody>
+      </p:sp>
+      <p:sp>
+        <p:nvSpPr>
+          <p:cNvPr id="12" name="TextBox 11"/>
+          <p:cNvSpPr txBox="1"/>
+          <p:nvPr/>
+        </p:nvSpPr>
+        <p:spPr>
+          <a:xfrm>
+            <a:off x="548640" y="5257800"/>
+            <a:ext cx="3291840" cy="365760"/>
+          </a:xfrm>
+          <a:prstGeom prst="rect">
+            <a:avLst/>
+          </a:prstGeom>
+          <a:noFill/>
+        </p:spPr>
+        <p:txBody>
+          <a:bodyPr wrap="square"/>
+          <a:lstStyle/>
+          <a:p>
+            <a:pPr algn="ctr">
+              <a:spcBef>
+                <a:spcPts val="200"/>
+              </a:spcBef>
+              <a:spcAft>
+                <a:spcPts val="200"/>
+              </a:spcAft>
+              <a:defRPr sz="1600" b="1" i="1">
+                <a:solidFill>
+                  <a:srgbClr val="FFD600"/>
+                </a:solidFill>
+                <a:latin typeface="Inter"/>
+              </a:defRPr>
+            </a:pPr>
+            <a:r>
+              <a:t>Industrialisation</a:t>
+            </a:r>
+          </a:p>
+        </p:txBody>
+      </p:sp>
+      <p:sp>
+        <p:nvSpPr>
+          <p:cNvPr id="13" name="Rounded Rectangle 12"/>
+          <p:cNvSpPr/>
+          <p:nvPr/>
+        </p:nvSpPr>
+        <p:spPr>
+          <a:xfrm>
+            <a:off x="4297680" y="1371600"/>
+            <a:ext cx="3474720" cy="4754880"/>
+          </a:xfrm>
+          <a:prstGeom prst="roundRect">
+            <a:avLst>
+              <a:gd name="adj" fmla="val 15000"/>
+            </a:avLst>
+          </a:prstGeom>
+          <a:solidFill>
+            <a:srgbClr val="1A1F2E"/>
+          </a:solidFill>
+          <a:ln w="19050">
+            <a:solidFill>
+              <a:srgbClr val="00E676"/>
+            </a:solidFill>
+          </a:ln>
+        </p:spPr>
+        <p:style>
+          <a:lnRef idx="1">
+            <a:schemeClr val="accent1"/>
+          </a:lnRef>
+          <a:fillRef idx="3">
+            <a:schemeClr val="accent1"/>
+          </a:fillRef>
+          <a:effectRef idx="2">
+            <a:schemeClr val="accent1"/>
+          </a:effectRef>
+          <a:fontRef idx="minor">
+            <a:schemeClr val="lt1"/>
+          </a:fontRef>
+        </p:style>
+        <p:txBody>
+          <a:bodyPr rtlCol="0" anchor="ctr"/>
+          <a:lstStyle/>
+          <a:p>
+            <a:pPr algn="ctr"/>
+          </a:p>
+        </p:txBody>
+      </p:sp>
+      <p:sp>
+        <p:nvSpPr>
+          <p:cNvPr id="14" name="TextBox 13"/>
+          <p:cNvSpPr txBox="1"/>
+          <p:nvPr/>
+        </p:nvSpPr>
+        <p:spPr>
+          <a:xfrm>
+            <a:off x="4389120" y="1554480"/>
+            <a:ext cx="3291840" cy="548640"/>
+          </a:xfrm>
+          <a:prstGeom prst="rect">
+            <a:avLst/>
+          </a:prstGeom>
+          <a:noFill/>
+        </p:spPr>
+        <p:txBody>
+          <a:bodyPr wrap="square"/>
+          <a:lstStyle/>
+          <a:p>
+            <a:pPr algn="ctr">
+              <a:spcBef>
+                <a:spcPts val="200"/>
+              </a:spcBef>
+              <a:spcAft>
+                <a:spcPts val="200"/>
+              </a:spcAft>
+              <a:defRPr sz="4000" b="1" i="0">
+                <a:solidFill>
+                  <a:srgbClr val="00E676"/>
+                </a:solidFill>
+                <a:latin typeface="Inter"/>
+              </a:defRPr>
+            </a:pPr>
+            <a:r>
+              <a:t>V11</a:t>
+            </a:r>
+          </a:p>
+        </p:txBody>
+      </p:sp>
+      <p:sp>
+        <p:nvSpPr>
+          <p:cNvPr id="15" name="TextBox 14"/>
+          <p:cNvSpPr txBox="1"/>
+          <p:nvPr/>
+        </p:nvSpPr>
+        <p:spPr>
+          <a:xfrm>
+            <a:off x="4389120" y="2148840"/>
+            <a:ext cx="3291840" cy="320040"/>
+          </a:xfrm>
+          <a:prstGeom prst="rect">
+            <a:avLst/>
+          </a:prstGeom>
+          <a:noFill/>
+        </p:spPr>
+        <p:txBody>
+          <a:bodyPr wrap="square"/>
+          <a:lstStyle/>
+          <a:p>
+            <a:pPr algn="ctr">
+              <a:spcBef>
+                <a:spcPts val="200"/>
+              </a:spcBef>
+              <a:spcAft>
+                <a:spcPts val="200"/>
+              </a:spcAft>
+              <a:defRPr sz="2000" b="0" i="0">
+                <a:solidFill>
+                  <a:srgbClr val="B0B0B0"/>
+                </a:solidFill>
+                <a:latin typeface="Inter"/>
+              </a:defRPr>
+            </a:pPr>
+            <a:r>
+              <a:t>Q4 2026</a:t>
+            </a:r>
+          </a:p>
+        </p:txBody>
+      </p:sp>
+      <p:sp>
+        <p:nvSpPr>
+          <p:cNvPr id="16" name="Rectangle 15"/>
+          <p:cNvSpPr/>
+          <p:nvPr/>
+        </p:nvSpPr>
+        <p:spPr>
+          <a:xfrm>
+            <a:off x="4572000" y="2606040"/>
+            <a:ext cx="2926080" cy="12700"/>
+          </a:xfrm>
+          <a:prstGeom prst="rect">
+            <a:avLst/>
+          </a:prstGeom>
+          <a:solidFill>
+            <a:srgbClr val="2A2F3E"/>
+          </a:solidFill>
+          <a:ln>
+            <a:noFill/>
+          </a:ln>
+        </p:spPr>
+        <p:style>
+          <a:lnRef idx="1">
+            <a:schemeClr val="accent1"/>
+          </a:lnRef>
+          <a:fillRef idx="3">
+            <a:schemeClr val="accent1"/>
+          </a:fillRef>
+          <a:effectRef idx="2">
+            <a:schemeClr val="accent1"/>
+          </a:effectRef>
+          <a:fontRef idx="minor">
+            <a:schemeClr val="lt1"/>
+          </a:fontRef>
+        </p:style>
+        <p:txBody>
+          <a:bodyPr rtlCol="0" anchor="ctr"/>
+          <a:lstStyle/>
+          <a:p>
+            <a:pPr algn="ctr"/>
+          </a:p>
+        </p:txBody>
+      </p:sp>
+      <p:sp>
+        <p:nvSpPr>
+          <p:cNvPr id="17" name="TextBox 16"/>
+          <p:cNvSpPr txBox="1"/>
+          <p:nvPr/>
+        </p:nvSpPr>
+        <p:spPr>
+          <a:xfrm>
+            <a:off x="4663440" y="2834640"/>
+            <a:ext cx="2926080" cy="457200"/>
+          </a:xfrm>
+          <a:prstGeom prst="rect">
+            <a:avLst/>
+          </a:prstGeom>
+          <a:noFill/>
+        </p:spPr>
+        <p:txBody>
+          <a:bodyPr wrap="square"/>
+          <a:lstStyle/>
+          <a:p>
+            <a:pPr algn="l">
+              <a:spcBef>
+                <a:spcPts val="200"/>
+              </a:spcBef>
+              <a:spcAft>
+                <a:spcPts val="200"/>
+              </a:spcAft>
+              <a:defRPr sz="1700" b="0" i="0">
+                <a:solidFill>
+                  <a:srgbClr val="E8E8E8"/>
+                </a:solidFill>
+                <a:latin typeface="Inter"/>
+              </a:defRPr>
+            </a:pPr>
+            <a:r>
+              <a:t>•  ClaimBuster intégration</a:t>
+            </a:r>
+          </a:p>
+        </p:txBody>
+      </p:sp>
+      <p:sp>
+        <p:nvSpPr>
+          <p:cNvPr id="18" name="TextBox 17"/>
+          <p:cNvSpPr txBox="1"/>
+          <p:nvPr/>
+        </p:nvSpPr>
+        <p:spPr>
+          <a:xfrm>
+            <a:off x="4663440" y="3383280"/>
+            <a:ext cx="2926080" cy="457200"/>
+          </a:xfrm>
+          <a:prstGeom prst="rect">
+            <a:avLst/>
+          </a:prstGeom>
+          <a:noFill/>
+        </p:spPr>
+        <p:txBody>
+          <a:bodyPr wrap="square"/>
+          <a:lstStyle/>
+          <a:p>
+            <a:pPr algn="l">
+              <a:spcBef>
+                <a:spcPts val="200"/>
+              </a:spcBef>
+              <a:spcAft>
+                <a:spcPts val="200"/>
+              </a:spcAft>
+              <a:defRPr sz="1700" b="0" i="0">
+                <a:solidFill>
+                  <a:srgbClr val="E8E8E8"/>
+                </a:solidFill>
+                <a:latin typeface="Inter"/>
+              </a:defRPr>
+            </a:pPr>
+            <a:r>
+              <a:t>•  Monitoring Grafana</a:t>
+            </a:r>
+          </a:p>
+        </p:txBody>
+      </p:sp>
+      <p:sp>
+        <p:nvSpPr>
+          <p:cNvPr id="19" name="TextBox 18"/>
+          <p:cNvSpPr txBox="1"/>
+          <p:nvPr/>
+        </p:nvSpPr>
+        <p:spPr>
+          <a:xfrm>
+            <a:off x="4663440" y="3931920"/>
+            <a:ext cx="2926080" cy="457200"/>
+          </a:xfrm>
+          <a:prstGeom prst="rect">
+            <a:avLst/>
+          </a:prstGeom>
+          <a:noFill/>
+        </p:spPr>
+        <p:txBody>
+          <a:bodyPr wrap="square"/>
+          <a:lstStyle/>
+          <a:p>
+            <a:pPr algn="l">
+              <a:spcBef>
+                <a:spcPts val="200"/>
+              </a:spcBef>
+              <a:spcAft>
+                <a:spcPts val="200"/>
+              </a:spcAft>
+              <a:defRPr sz="1700" b="0" i="0">
+                <a:solidFill>
+                  <a:srgbClr val="E8E8E8"/>
+                </a:solidFill>
+                <a:latin typeface="Inter"/>
+              </a:defRPr>
+            </a:pPr>
+            <a:r>
+              <a:t>•  Tests E2E nightly</a:t>
+            </a:r>
+          </a:p>
+        </p:txBody>
+      </p:sp>
+      <p:sp>
+        <p:nvSpPr>
+          <p:cNvPr id="20" name="Rectangle 19"/>
+          <p:cNvSpPr/>
+          <p:nvPr/>
+        </p:nvSpPr>
+        <p:spPr>
+          <a:xfrm>
+            <a:off x="4572000" y="5120640"/>
+            <a:ext cx="2926080" cy="12700"/>
+          </a:xfrm>
+          <a:prstGeom prst="rect">
+            <a:avLst/>
+          </a:prstGeom>
+          <a:solidFill>
+            <a:srgbClr val="2A2F3E"/>
+          </a:solidFill>
+          <a:ln>
+            <a:noFill/>
+          </a:ln>
+        </p:spPr>
+        <p:style>
+          <a:lnRef idx="1">
+            <a:schemeClr val="accent1"/>
+          </a:lnRef>
+          <a:fillRef idx="3">
+            <a:schemeClr val="accent1"/>
+          </a:fillRef>
+          <a:effectRef idx="2">
+            <a:schemeClr val="accent1"/>
+          </a:effectRef>
+          <a:fontRef idx="minor">
+            <a:schemeClr val="lt1"/>
+          </a:fontRef>
+        </p:style>
+        <p:txBody>
+          <a:bodyPr rtlCol="0" anchor="ctr"/>
+          <a:lstStyle/>
+          <a:p>
+            <a:pPr algn="ctr"/>
+          </a:p>
+        </p:txBody>
+      </p:sp>
+      <p:sp>
+        <p:nvSpPr>
+          <p:cNvPr id="21" name="TextBox 20"/>
+          <p:cNvSpPr txBox="1"/>
+          <p:nvPr/>
+        </p:nvSpPr>
+        <p:spPr>
+          <a:xfrm>
+            <a:off x="4389120" y="5257800"/>
+            <a:ext cx="3291840" cy="365760"/>
+          </a:xfrm>
+          <a:prstGeom prst="rect">
+            <a:avLst/>
+          </a:prstGeom>
+          <a:noFill/>
+        </p:spPr>
+        <p:txBody>
+          <a:bodyPr wrap="square"/>
+          <a:lstStyle/>
+          <a:p>
+            <a:pPr algn="ctr">
+              <a:spcBef>
+                <a:spcPts val="200"/>
+              </a:spcBef>
+              <a:spcAft>
+                <a:spcPts val="200"/>
+              </a:spcAft>
+              <a:defRPr sz="1600" b="1" i="1">
+                <a:solidFill>
+                  <a:srgbClr val="FFD600"/>
+                </a:solidFill>
+                <a:latin typeface="Inter"/>
+              </a:defRPr>
+            </a:pPr>
+            <a:r>
+              <a:t>Vérif. factuelle</a:t>
+            </a:r>
+          </a:p>
+        </p:txBody>
+      </p:sp>
+      <p:sp>
+        <p:nvSpPr>
+          <p:cNvPr id="22" name="Rounded Rectangle 21"/>
+          <p:cNvSpPr/>
+          <p:nvPr/>
+        </p:nvSpPr>
+        <p:spPr>
+          <a:xfrm>
+            <a:off x="8138160" y="1371600"/>
+            <a:ext cx="3474720" cy="4754880"/>
+          </a:xfrm>
+          <a:prstGeom prst="roundRect">
+            <a:avLst>
+              <a:gd name="adj" fmla="val 15000"/>
+            </a:avLst>
+          </a:prstGeom>
+          <a:solidFill>
+            <a:srgbClr val="1A1F2E"/>
+          </a:solidFill>
+          <a:ln w="19050">
+            <a:solidFill>
+              <a:srgbClr val="FFD600"/>
+            </a:solidFill>
+          </a:ln>
+        </p:spPr>
+        <p:style>
+          <a:lnRef idx="1">
+            <a:schemeClr val="accent1"/>
+          </a:lnRef>
+          <a:fillRef idx="3">
+            <a:schemeClr val="accent1"/>
+          </a:fillRef>
+          <a:effectRef idx="2">
+            <a:schemeClr val="accent1"/>
+          </a:effectRef>
+          <a:fontRef idx="minor">
+            <a:schemeClr val="lt1"/>
+          </a:fontRef>
+        </p:style>
+        <p:txBody>
+          <a:bodyPr rtlCol="0" anchor="ctr"/>
+          <a:lstStyle/>
+          <a:p>
+            <a:pPr algn="ctr"/>
+          </a:p>
+        </p:txBody>
+      </p:sp>
+      <p:sp>
+        <p:nvSpPr>
+          <p:cNvPr id="23" name="TextBox 22"/>
+          <p:cNvSpPr txBox="1"/>
+          <p:nvPr/>
+        </p:nvSpPr>
+        <p:spPr>
+          <a:xfrm>
+            <a:off x="8229600" y="1554480"/>
+            <a:ext cx="3291840" cy="548640"/>
+          </a:xfrm>
+          <a:prstGeom prst="rect">
+            <a:avLst/>
+          </a:prstGeom>
+          <a:noFill/>
+        </p:spPr>
+        <p:txBody>
+          <a:bodyPr wrap="square"/>
+          <a:lstStyle/>
+          <a:p>
+            <a:pPr algn="ctr">
+              <a:spcBef>
+                <a:spcPts val="200"/>
+              </a:spcBef>
+              <a:spcAft>
+                <a:spcPts val="200"/>
+              </a:spcAft>
+              <a:defRPr sz="4000" b="1" i="0">
+                <a:solidFill>
+                  <a:srgbClr val="FFD600"/>
+                </a:solidFill>
+                <a:latin typeface="Inter"/>
+              </a:defRPr>
+            </a:pPr>
+            <a:r>
+              <a:t>V12</a:t>
+            </a:r>
+          </a:p>
+        </p:txBody>
+      </p:sp>
+      <p:sp>
+        <p:nvSpPr>
+          <p:cNvPr id="24" name="TextBox 23"/>
+          <p:cNvSpPr txBox="1"/>
+          <p:nvPr/>
+        </p:nvSpPr>
+        <p:spPr>
+          <a:xfrm>
+            <a:off x="8229600" y="2148840"/>
+            <a:ext cx="3291840" cy="320040"/>
+          </a:xfrm>
+          <a:prstGeom prst="rect">
+            <a:avLst/>
+          </a:prstGeom>
+          <a:noFill/>
+        </p:spPr>
+        <p:txBody>
+          <a:bodyPr wrap="square"/>
+          <a:lstStyle/>
+          <a:p>
+            <a:pPr algn="ctr">
+              <a:spcBef>
+                <a:spcPts val="200"/>
+              </a:spcBef>
+              <a:spcAft>
+                <a:spcPts val="200"/>
+              </a:spcAft>
+              <a:defRPr sz="2000" b="0" i="0">
+                <a:solidFill>
+                  <a:srgbClr val="B0B0B0"/>
+                </a:solidFill>
+                <a:latin typeface="Inter"/>
+              </a:defRPr>
+            </a:pPr>
+            <a:r>
+              <a:t>2027</a:t>
+            </a:r>
+          </a:p>
+        </p:txBody>
+      </p:sp>
+      <p:sp>
+        <p:nvSpPr>
+          <p:cNvPr id="25" name="Rectangle 24"/>
+          <p:cNvSpPr/>
+          <p:nvPr/>
+        </p:nvSpPr>
+        <p:spPr>
+          <a:xfrm>
+            <a:off x="8412480" y="2606040"/>
+            <a:ext cx="2926080" cy="12700"/>
+          </a:xfrm>
+          <a:prstGeom prst="rect">
+            <a:avLst/>
+          </a:prstGeom>
+          <a:solidFill>
+            <a:srgbClr val="2A2F3E"/>
+          </a:solidFill>
+          <a:ln>
+            <a:noFill/>
+          </a:ln>
+        </p:spPr>
+        <p:style>
+          <a:lnRef idx="1">
+            <a:schemeClr val="accent1"/>
+          </a:lnRef>
+          <a:fillRef idx="3">
+            <a:schemeClr val="accent1"/>
+          </a:fillRef>
+          <a:effectRef idx="2">
+            <a:schemeClr val="accent1"/>
+          </a:effectRef>
+          <a:fontRef idx="minor">
+            <a:schemeClr val="lt1"/>
+          </a:fontRef>
+        </p:style>
+        <p:txBody>
+          <a:bodyPr rtlCol="0" anchor="ctr"/>
+          <a:lstStyle/>
+          <a:p>
+            <a:pPr algn="ctr"/>
+          </a:p>
+        </p:txBody>
+      </p:sp>
+      <p:sp>
+        <p:nvSpPr>
+          <p:cNvPr id="26" name="TextBox 25"/>
+          <p:cNvSpPr txBox="1"/>
+          <p:nvPr/>
+        </p:nvSpPr>
+        <p:spPr>
+          <a:xfrm>
+            <a:off x="8503920" y="2834640"/>
+            <a:ext cx="2926080" cy="457200"/>
+          </a:xfrm>
+          <a:prstGeom prst="rect">
+            <a:avLst/>
+          </a:prstGeom>
+          <a:noFill/>
+        </p:spPr>
+        <p:txBody>
+          <a:bodyPr wrap="square"/>
+          <a:lstStyle/>
+          <a:p>
+            <a:pPr algn="l">
+              <a:spcBef>
+                <a:spcPts val="200"/>
+              </a:spcBef>
+              <a:spcAft>
+                <a:spcPts val="200"/>
+              </a:spcAft>
+              <a:defRPr sz="1700" b="0" i="0">
+                <a:solidFill>
+                  <a:srgbClr val="E8E8E8"/>
+                </a:solidFill>
+                <a:latin typeface="Inter"/>
+              </a:defRPr>
+            </a:pPr>
+            <a:r>
+              <a:t>•  Modèle FR spécialisé</a:t>
+            </a:r>
+          </a:p>
+        </p:txBody>
+      </p:sp>
+      <p:sp>
+        <p:nvSpPr>
+          <p:cNvPr id="27" name="TextBox 26"/>
+          <p:cNvSpPr txBox="1"/>
+          <p:nvPr/>
+        </p:nvSpPr>
+        <p:spPr>
+          <a:xfrm>
+            <a:off x="8503920" y="3383280"/>
+            <a:ext cx="2926080" cy="457200"/>
+          </a:xfrm>
+          <a:prstGeom prst="rect">
+            <a:avLst/>
+          </a:prstGeom>
+          <a:noFill/>
+        </p:spPr>
+        <p:txBody>
+          <a:bodyPr wrap="square"/>
+          <a:lstStyle/>
+          <a:p>
+            <a:pPr algn="l">
+              <a:spcBef>
+                <a:spcPts val="200"/>
+              </a:spcBef>
+              <a:spcAft>
+                <a:spcPts val="200"/>
+              </a:spcAft>
+              <a:defRPr sz="1700" b="0" i="0">
+                <a:solidFill>
+                  <a:srgbClr val="E8E8E8"/>
+                </a:solidFill>
+                <a:latin typeface="Inter"/>
+              </a:defRPr>
+            </a:pPr>
+            <a:r>
+              <a:t>•  Annotation communautaire</a:t>
+            </a:r>
+          </a:p>
+        </p:txBody>
+      </p:sp>
+      <p:sp>
+        <p:nvSpPr>
+          <p:cNvPr id="28" name="TextBox 27"/>
+          <p:cNvSpPr txBox="1"/>
+          <p:nvPr/>
+        </p:nvSpPr>
+        <p:spPr>
+          <a:xfrm>
+            <a:off x="8503920" y="3931920"/>
+            <a:ext cx="2926080" cy="457200"/>
+          </a:xfrm>
+          <a:prstGeom prst="rect">
+            <a:avLst/>
+          </a:prstGeom>
+          <a:noFill/>
+        </p:spPr>
+        <p:txBody>
+          <a:bodyPr wrap="square"/>
+          <a:lstStyle/>
+          <a:p>
+            <a:pPr algn="l">
+              <a:spcBef>
+                <a:spcPts val="200"/>
+              </a:spcBef>
+              <a:spcAft>
+                <a:spcPts val="200"/>
+              </a:spcAft>
+              <a:defRPr sz="1700" b="0" i="0">
+                <a:solidFill>
+                  <a:srgbClr val="E8E8E8"/>
+                </a:solidFill>
+                <a:latin typeface="Inter"/>
+              </a:defRPr>
+            </a:pPr>
+            <a:r>
+              <a:t>•  Federated learning</a:t>
+            </a:r>
+          </a:p>
+        </p:txBody>
+      </p:sp>
+      <p:sp>
+        <p:nvSpPr>
+          <p:cNvPr id="29" name="Rectangle 28"/>
+          <p:cNvSpPr/>
+          <p:nvPr/>
+        </p:nvSpPr>
+        <p:spPr>
+          <a:xfrm>
+            <a:off x="8412480" y="5120640"/>
+            <a:ext cx="2926080" cy="12700"/>
+          </a:xfrm>
+          <a:prstGeom prst="rect">
+            <a:avLst/>
+          </a:prstGeom>
+          <a:solidFill>
+            <a:srgbClr val="2A2F3E"/>
+          </a:solidFill>
+          <a:ln>
+            <a:noFill/>
+          </a:ln>
+        </p:spPr>
+        <p:style>
+          <a:lnRef idx="1">
+            <a:schemeClr val="accent1"/>
+          </a:lnRef>
+          <a:fillRef idx="3">
+            <a:schemeClr val="accent1"/>
+          </a:fillRef>
+          <a:effectRef idx="2">
+            <a:schemeClr val="accent1"/>
+          </a:effectRef>
+          <a:fontRef idx="minor">
+            <a:schemeClr val="lt1"/>
+          </a:fontRef>
+        </p:style>
+        <p:txBody>
+          <a:bodyPr rtlCol="0" anchor="ctr"/>
+          <a:lstStyle/>
+          <a:p>
+            <a:pPr algn="ctr"/>
+          </a:p>
+        </p:txBody>
+      </p:sp>
+      <p:sp>
+        <p:nvSpPr>
+          <p:cNvPr id="30" name="TextBox 29"/>
+          <p:cNvSpPr txBox="1"/>
+          <p:nvPr/>
+        </p:nvSpPr>
+        <p:spPr>
+          <a:xfrm>
+            <a:off x="8229600" y="5257800"/>
+            <a:ext cx="3291840" cy="365760"/>
+          </a:xfrm>
+          <a:prstGeom prst="rect">
+            <a:avLst/>
+          </a:prstGeom>
+          <a:noFill/>
+        </p:spPr>
+        <p:txBody>
+          <a:bodyPr wrap="square"/>
+          <a:lstStyle/>
+          <a:p>
+            <a:pPr algn="ctr">
+              <a:spcBef>
+                <a:spcPts val="200"/>
+              </a:spcBef>
+              <a:spcAft>
+                <a:spcPts val="200"/>
+              </a:spcAft>
+              <a:defRPr sz="1600" b="1" i="1">
+                <a:solidFill>
+                  <a:srgbClr val="FFD600"/>
+                </a:solidFill>
+                <a:latin typeface="Inter"/>
+              </a:defRPr>
+            </a:pPr>
+            <a:r>
+              <a:t>Inclusion</a:t>
+            </a:r>
+          </a:p>
+        </p:txBody>
+      </p:sp>
+      <p:sp>
+        <p:nvSpPr>
+          <p:cNvPr id="31" name="TextBox 30"/>
+          <p:cNvSpPr txBox="1"/>
+          <p:nvPr/>
+        </p:nvSpPr>
+        <p:spPr>
+          <a:xfrm>
+            <a:off x="8229600" y="6400800"/>
+            <a:ext cx="3657600" cy="320040"/>
+          </a:xfrm>
+          <a:prstGeom prst="rect">
+            <a:avLst/>
+          </a:prstGeom>
+          <a:noFill/>
+        </p:spPr>
+        <p:txBody>
+          <a:bodyPr wrap="none">
+            <a:spAutoFit/>
+          </a:bodyPr>
+          <a:lstStyle/>
+          <a:p>
+            <a:pPr algn="r">
+              <a:defRPr sz="1300">
+                <a:solidFill>
+                  <a:srgbClr val="606060"/>
+                </a:solidFill>
+                <a:latin typeface="Inter"/>
+              </a:defRPr>
+            </a:pPr>
+            <a:r>
+              <a:t>Niamato Consulting  ·  Thumalien V9  ·  M1 BDIA 2026</a:t>
+            </a:r>
+          </a:p>
+        </p:txBody>
+      </p:sp>
+      <p:sp>
+        <p:nvSpPr>
+          <p:cNvPr id="32" name="TextBox 31"/>
+          <p:cNvSpPr txBox="1"/>
+          <p:nvPr/>
+        </p:nvSpPr>
+        <p:spPr>
+          <a:xfrm>
+            <a:off x="365760" y="6400800"/>
+            <a:ext cx="1097280" cy="320040"/>
+          </a:xfrm>
+          <a:prstGeom prst="rect">
+            <a:avLst/>
+          </a:prstGeom>
+          <a:noFill/>
+        </p:spPr>
+        <p:txBody>
+          <a:bodyPr wrap="none">
+            <a:spAutoFit/>
+          </a:bodyPr>
+          <a:lstStyle/>
+          <a:p>
+            <a:pPr algn="l">
+              <a:defRPr sz="1200">
+                <a:solidFill>
+                  <a:srgbClr val="606060"/>
+                </a:solidFill>
+                <a:latin typeface="Inter"/>
+              </a:defRPr>
+            </a:pPr>
+            <a:r>
+              <a:t>15 / 17</a:t>
+            </a:r>
+          </a:p>
+        </p:txBody>
+      </p:sp>
+    </p:spTree>
+  </p:cSld>
+  <p:clrMapOvr>
+    <a:masterClrMapping/>
+  </p:clrMapOvr>
+</p:sld>
+</file>
+
+<file path=ppt/slides/slide16.xml><?xml version="1.0" encoding="utf-8"?>
 <p:sld xmlns:a="http://schemas.openxmlformats.org/drawingml/2006/main" xmlns:p="http://schemas.openxmlformats.org/presentationml/2006/main" xmlns:r="http://schemas.openxmlformats.org/officeDocument/2006/relationships">
   <p:cSld>
     <p:bg>
@@ -12645,7 +13966,7 @@
 </p:sld>
 </file>
 
-<file path=ppt/slides/slide16.xml><?xml version="1.0" encoding="utf-8"?>
+<file path=ppt/slides/slide17.xml><?xml version="1.0" encoding="utf-8"?>
 <p:sld xmlns:a="http://schemas.openxmlformats.org/drawingml/2006/main" xmlns:p="http://schemas.openxmlformats.org/presentationml/2006/main" xmlns:r="http://schemas.openxmlformats.org/officeDocument/2006/relationships">
   <p:cSld>
     <p:bg>
@@ -13321,7 +14642,7 @@
               </a:defRPr>
             </a:pPr>
             <a:r>
-              <a:t>Thumalien V9  ·  M1 BDIA 2026</a:t>
+              <a:t>Niamato Consulting  ·  Thumalien V9  ·  M1 BDIA 2026</a:t>
             </a:r>
           </a:p>
         </p:txBody>
@@ -13386,7 +14707,7 @@
               </a:defRPr>
             </a:pPr>
             <a:r>
-              <a:t>L'ÉQUIPE THUMALIEN</a:t>
+              <a:t>NIAMATO CONSULTING — L'ÉQUIPE</a:t>
             </a:r>
           </a:p>
         </p:txBody>
@@ -14376,7 +15697,7 @@
               </a:defRPr>
             </a:pPr>
             <a:r>
-              <a:t>Thumalien V9  ·  M1 BDIA 2026</a:t>
+              <a:t>Niamato Consulting  ·  Thumalien V9  ·  M1 BDIA 2026</a:t>
             </a:r>
           </a:p>
         </p:txBody>
@@ -14412,7 +15733,7 @@
               </a:defRPr>
             </a:pPr>
             <a:r>
-              <a:t>2 / 16</a:t>
+              <a:t>2 / 17</a:t>
             </a:r>
           </a:p>
         </p:txBody>
@@ -15021,7 +16342,7 @@
               </a:defRPr>
             </a:pPr>
             <a:r>
-              <a:t>Thumalien V9  ·  M1 BDIA 2026</a:t>
+              <a:t>Niamato Consulting  ·  Thumalien V9  ·  M1 BDIA 2026</a:t>
             </a:r>
           </a:p>
         </p:txBody>
@@ -15057,7 +16378,7 @@
               </a:defRPr>
             </a:pPr>
             <a:r>
-              <a:t>3 / 16</a:t>
+              <a:t>3 / 17</a:t>
             </a:r>
           </a:p>
         </p:txBody>
@@ -15866,7 +17187,7 @@
               </a:defRPr>
             </a:pPr>
             <a:r>
-              <a:t>Thumalien V9  ·  M1 BDIA 2026</a:t>
+              <a:t>Niamato Consulting  ·  Thumalien V9  ·  M1 BDIA 2026</a:t>
             </a:r>
           </a:p>
         </p:txBody>
@@ -15902,7 +17223,7 @@
               </a:defRPr>
             </a:pPr>
             <a:r>
-              <a:t>4 / 16</a:t>
+              <a:t>4 / 17</a:t>
             </a:r>
           </a:p>
         </p:txBody>
@@ -17165,7 +18486,7 @@
               </a:defRPr>
             </a:pPr>
             <a:r>
-              <a:t>Thumalien V9  ·  M1 BDIA 2026</a:t>
+              <a:t>Niamato Consulting  ·  Thumalien V9  ·  M1 BDIA 2026</a:t>
             </a:r>
           </a:p>
         </p:txBody>
@@ -17201,7 +18522,7 @@
               </a:defRPr>
             </a:pPr>
             <a:r>
-              <a:t>5 / 16</a:t>
+              <a:t>5 / 17</a:t>
             </a:r>
           </a:p>
         </p:txBody>
@@ -18186,7 +19507,7 @@
               </a:defRPr>
             </a:pPr>
             <a:r>
-              <a:t>C4 Model — Niveau 2 (Container)  |  Docker Compose  |  FastAPI</a:t>
+              <a:t>Données → IA → Décision  |  C4 Model  |  Docker Compose  |  FastAPI</a:t>
             </a:r>
           </a:p>
         </p:txBody>
@@ -18222,7 +19543,7 @@
               </a:defRPr>
             </a:pPr>
             <a:r>
-              <a:t>Thumalien V9  ·  M1 BDIA 2026</a:t>
+              <a:t>Niamato Consulting  ·  Thumalien V9  ·  M1 BDIA 2026</a:t>
             </a:r>
           </a:p>
         </p:txBody>
@@ -18258,7 +19579,7 @@
               </a:defRPr>
             </a:pPr>
             <a:r>
-              <a:t>6 / 16</a:t>
+              <a:t>6 / 17</a:t>
             </a:r>
           </a:p>
         </p:txBody>
@@ -20143,7 +21464,7 @@
               </a:defRPr>
             </a:pPr>
             <a:r>
-              <a:t>Thumalien V9  ·  M1 BDIA 2026</a:t>
+              <a:t>Niamato Consulting  ·  Thumalien V9  ·  M1 BDIA 2026</a:t>
             </a:r>
           </a:p>
         </p:txBody>
@@ -20179,7 +21500,7 @@
               </a:defRPr>
             </a:pPr>
             <a:r>
-              <a:t>7 / 16</a:t>
+              <a:t>7 / 17</a:t>
             </a:r>
           </a:p>
         </p:txBody>
@@ -20796,7 +22117,7 @@
               </a:defRPr>
             </a:pPr>
             <a:r>
-              <a:t>Thumalien V9  ·  M1 BDIA 2026</a:t>
+              <a:t>Niamato Consulting  ·  Thumalien V9  ·  M1 BDIA 2026</a:t>
             </a:r>
           </a:p>
         </p:txBody>
@@ -20832,7 +22153,7 @@
               </a:defRPr>
             </a:pPr>
             <a:r>
-              <a:t>8 / 16</a:t>
+              <a:t>8 / 17</a:t>
             </a:r>
           </a:p>
         </p:txBody>
@@ -21712,7 +23033,7 @@
               </a:defRPr>
             </a:pPr>
             <a:r>
-              <a:t>Thumalien V9  ·  M1 BDIA 2026</a:t>
+              <a:t>Niamato Consulting  ·  Thumalien V9  ·  M1 BDIA 2026</a:t>
             </a:r>
           </a:p>
         </p:txBody>
@@ -21748,7 +23069,7 @@
               </a:defRPr>
             </a:pPr>
             <a:r>
-              <a:t>9 / 16</a:t>
+              <a:t>9 / 17</a:t>
             </a:r>
           </a:p>
         </p:txBody>

</xml_diff>

<commit_message>
feat(video): ajout budget projet dans slide ROI + script v3
Slide 14 ROI restructuree en 2 panneaux:
- Gauche: ROI (temps x10, volume x200, risque -67%, cout ~0)
- Droite: Budget detaille (RH 49.5K, infra 0, licences 0, annotation 750)
  Total projet: 50 250 EUR, exploitation: ~930 EUR/mois
  Cout/post: 0.0005 ct (quasi gratuit)

Script v3 mis a jour avec voix-off budget Sebastien.
</commit_message>
<xml_diff>
--- a/video_mvp/Thumalien_V9_slides.pptx
+++ b/video_mvp/Thumalien_V9_slides.pptx
@@ -1162,7 +1162,7 @@
           <a:lstStyle/>
           <a:p>
             <a:r>
-              <a:t>SLIDE 14 — ROI (15:45 → 16:30)</a:t>
+              <a:t>SLIDE 14 — ROI &amp; BUDGET (15:45 → 16:30)</a:t>
             </a:r>
           </a:p>
           <a:p>
@@ -1183,27 +1183,75 @@
           </a:p>
           <a:p>
             <a:r>
-              <a:t>« Voici le retour sur investissement concret.</a:t>
-            </a:r>
-          </a:p>
-          <a:p>
-            <a:r>
-              <a:t>En temps : un modérateur passe de 5 minutes à 30 secondes par post.</a:t>
-            </a:r>
-          </a:p>
-          <a:p>
-            <a:r>
-              <a:t>En volume : 60 000 posts par jour traités automatiquement.</a:t>
-            </a:r>
-          </a:p>
-          <a:p>
-            <a:r>
-              <a:t>En risque : conformité AI Act intégrée, faux positifs réduits de 67 %.</a:t>
-            </a:r>
-          </a:p>
-          <a:p>
-            <a:r>
-              <a:t>En coût : hébergé sur une machine à 22 watts, coût marginal quasi nul. »</a:t>
+              <a:t>« Parlons chiffres. Le projet Thumalien a coûté environ 50 000 euros,</a:t>
+            </a:r>
+          </a:p>
+          <a:p>
+            <a:r>
+              <a:t>essentiellement en ressources humaines — 110 jours-homme répartis</a:t>
+            </a:r>
+          </a:p>
+          <a:p>
+            <a:r>
+              <a:t>entre le développement technique et la validation.</a:t>
+            </a:r>
+          </a:p>
+          <a:p/>
+          <a:p>
+            <a:r>
+              <a:t>Zéro euro de licence : notre stack est 100 % open source.</a:t>
+            </a:r>
+          </a:p>
+          <a:p>
+            <a:r>
+              <a:t>Zéro euro de cloud : tout tourne en local sur Docker.</a:t>
+            </a:r>
+          </a:p>
+          <a:p>
+            <a:r>
+              <a:t>Le seul coût additionnel : 750 euros pour l'annotation manuelle</a:t>
+            </a:r>
+          </a:p>
+          <a:p>
+            <a:r>
+              <a:t>du gold set de validation.</a:t>
+            </a:r>
+          </a:p>
+          <a:p/>
+          <a:p>
+            <a:r>
+              <a:t>En exploitation, le coût mensuel est d'environ 930 euros :</a:t>
+            </a:r>
+          </a:p>
+          <a:p>
+            <a:r>
+              <a:t>un petit serveur à 30 euros et 2 jours de maintenance.</a:t>
+            </a:r>
+          </a:p>
+          <a:p>
+            <a:r>
+              <a:t>Pour 1,8 million de posts analysés par mois,</a:t>
+            </a:r>
+          </a:p>
+          <a:p>
+            <a:r>
+              <a:t>ça revient à 0,0005 centime par post.</a:t>
+            </a:r>
+          </a:p>
+          <a:p/>
+          <a:p>
+            <a:r>
+              <a:t>En retour : un gain de productivité x10 pour les modérateurs,</a:t>
+            </a:r>
+          </a:p>
+          <a:p>
+            <a:r>
+              <a:t>une couverture de 60 000 posts par jour — 200 fois plus qu'un humain —</a:t>
+            </a:r>
+          </a:p>
+          <a:p>
+            <a:r>
+              <a:t>et une réduction de 67 % des faux positifs. »</a:t>
             </a:r>
           </a:p>
         </p:txBody>
@@ -11425,7 +11473,7 @@
               </a:defRPr>
             </a:pPr>
             <a:r>
-              <a:t>ROI — VALEUR BUSINESS</a:t>
+              <a:t>ROI &amp; BUDGET — NIAMATO CONSULTING</a:t>
             </a:r>
           </a:p>
         </p:txBody>
@@ -11438,8 +11486,618 @@
         </p:nvSpPr>
         <p:spPr>
           <a:xfrm>
-            <a:off x="457200" y="1371600"/>
-            <a:ext cx="2697480" cy="4389120"/>
+            <a:off x="365760" y="1280160"/>
+            <a:ext cx="5852160" cy="4937760"/>
+          </a:xfrm>
+          <a:prstGeom prst="roundRect">
+            <a:avLst>
+              <a:gd name="adj" fmla="val 15000"/>
+            </a:avLst>
+          </a:prstGeom>
+          <a:solidFill>
+            <a:srgbClr val="1A1F2E"/>
+          </a:solidFill>
+          <a:ln w="19050">
+            <a:solidFill>
+              <a:srgbClr val="FFD600"/>
+            </a:solidFill>
+          </a:ln>
+        </p:spPr>
+        <p:style>
+          <a:lnRef idx="1">
+            <a:schemeClr val="accent1"/>
+          </a:lnRef>
+          <a:fillRef idx="3">
+            <a:schemeClr val="accent1"/>
+          </a:fillRef>
+          <a:effectRef idx="2">
+            <a:schemeClr val="accent1"/>
+          </a:effectRef>
+          <a:fontRef idx="minor">
+            <a:schemeClr val="lt1"/>
+          </a:fontRef>
+        </p:style>
+        <p:txBody>
+          <a:bodyPr rtlCol="0" anchor="ctr"/>
+          <a:lstStyle/>
+          <a:p>
+            <a:pPr algn="ctr"/>
+          </a:p>
+        </p:txBody>
+      </p:sp>
+      <p:sp>
+        <p:nvSpPr>
+          <p:cNvPr id="4" name="TextBox 3"/>
+          <p:cNvSpPr txBox="1"/>
+          <p:nvPr/>
+        </p:nvSpPr>
+        <p:spPr>
+          <a:xfrm>
+            <a:off x="548640" y="1417320"/>
+            <a:ext cx="5486400" cy="320040"/>
+          </a:xfrm>
+          <a:prstGeom prst="rect">
+            <a:avLst/>
+          </a:prstGeom>
+          <a:noFill/>
+        </p:spPr>
+        <p:txBody>
+          <a:bodyPr wrap="square"/>
+          <a:lstStyle/>
+          <a:p>
+            <a:pPr algn="ctr">
+              <a:spcBef>
+                <a:spcPts val="200"/>
+              </a:spcBef>
+              <a:spcAft>
+                <a:spcPts val="200"/>
+              </a:spcAft>
+              <a:defRPr sz="1600" b="1" i="0">
+                <a:solidFill>
+                  <a:srgbClr val="FFD600"/>
+                </a:solidFill>
+                <a:latin typeface="Inter"/>
+              </a:defRPr>
+            </a:pPr>
+            <a:r>
+              <a:t>RETOUR SUR INVESTISSEMENT</a:t>
+            </a:r>
+          </a:p>
+        </p:txBody>
+      </p:sp>
+      <p:sp>
+        <p:nvSpPr>
+          <p:cNvPr id="5" name="Rectangle 4"/>
+          <p:cNvSpPr/>
+          <p:nvPr/>
+        </p:nvSpPr>
+        <p:spPr>
+          <a:xfrm>
+            <a:off x="731520" y="1828800"/>
+            <a:ext cx="5120640" cy="12700"/>
+          </a:xfrm>
+          <a:prstGeom prst="rect">
+            <a:avLst/>
+          </a:prstGeom>
+          <a:solidFill>
+            <a:srgbClr val="2A2F3E"/>
+          </a:solidFill>
+          <a:ln>
+            <a:noFill/>
+          </a:ln>
+        </p:spPr>
+        <p:style>
+          <a:lnRef idx="1">
+            <a:schemeClr val="accent1"/>
+          </a:lnRef>
+          <a:fillRef idx="3">
+            <a:schemeClr val="accent1"/>
+          </a:fillRef>
+          <a:effectRef idx="2">
+            <a:schemeClr val="accent1"/>
+          </a:effectRef>
+          <a:fontRef idx="minor">
+            <a:schemeClr val="lt1"/>
+          </a:fontRef>
+        </p:style>
+        <p:txBody>
+          <a:bodyPr rtlCol="0" anchor="ctr"/>
+          <a:lstStyle/>
+          <a:p>
+            <a:pPr algn="ctr"/>
+          </a:p>
+        </p:txBody>
+      </p:sp>
+      <p:sp>
+        <p:nvSpPr>
+          <p:cNvPr id="6" name="TextBox 5"/>
+          <p:cNvSpPr txBox="1"/>
+          <p:nvPr/>
+        </p:nvSpPr>
+        <p:spPr>
+          <a:xfrm>
+            <a:off x="640080" y="1965960"/>
+            <a:ext cx="1097280" cy="274320"/>
+          </a:xfrm>
+          <a:prstGeom prst="rect">
+            <a:avLst/>
+          </a:prstGeom>
+          <a:noFill/>
+        </p:spPr>
+        <p:txBody>
+          <a:bodyPr wrap="square"/>
+          <a:lstStyle/>
+          <a:p>
+            <a:pPr algn="l">
+              <a:spcBef>
+                <a:spcPts val="200"/>
+              </a:spcBef>
+              <a:spcAft>
+                <a:spcPts val="200"/>
+              </a:spcAft>
+              <a:defRPr sz="1400" b="1" i="0">
+                <a:solidFill>
+                  <a:srgbClr val="00D4FF"/>
+                </a:solidFill>
+                <a:latin typeface="Inter"/>
+              </a:defRPr>
+            </a:pPr>
+            <a:r>
+              <a:t>TEMPS</a:t>
+            </a:r>
+          </a:p>
+        </p:txBody>
+      </p:sp>
+      <p:sp>
+        <p:nvSpPr>
+          <p:cNvPr id="7" name="TextBox 6"/>
+          <p:cNvSpPr txBox="1"/>
+          <p:nvPr/>
+        </p:nvSpPr>
+        <p:spPr>
+          <a:xfrm>
+            <a:off x="1828800" y="1874519"/>
+            <a:ext cx="1645920" cy="457200"/>
+          </a:xfrm>
+          <a:prstGeom prst="rect">
+            <a:avLst/>
+          </a:prstGeom>
+          <a:noFill/>
+        </p:spPr>
+        <p:txBody>
+          <a:bodyPr wrap="square"/>
+          <a:lstStyle/>
+          <a:p>
+            <a:pPr algn="ctr">
+              <a:spcBef>
+                <a:spcPts val="200"/>
+              </a:spcBef>
+              <a:spcAft>
+                <a:spcPts val="200"/>
+              </a:spcAft>
+              <a:defRPr sz="3600" b="1" i="0">
+                <a:solidFill>
+                  <a:srgbClr val="00D4FF"/>
+                </a:solidFill>
+                <a:latin typeface="Inter"/>
+              </a:defRPr>
+            </a:pPr>
+            <a:r>
+              <a:t>x10</a:t>
+            </a:r>
+          </a:p>
+        </p:txBody>
+      </p:sp>
+      <p:sp>
+        <p:nvSpPr>
+          <p:cNvPr id="8" name="TextBox 7"/>
+          <p:cNvSpPr txBox="1"/>
+          <p:nvPr/>
+        </p:nvSpPr>
+        <p:spPr>
+          <a:xfrm>
+            <a:off x="3566160" y="1984248"/>
+            <a:ext cx="2468880" cy="274320"/>
+          </a:xfrm>
+          <a:prstGeom prst="rect">
+            <a:avLst/>
+          </a:prstGeom>
+          <a:noFill/>
+        </p:spPr>
+        <p:txBody>
+          <a:bodyPr wrap="square"/>
+          <a:lstStyle/>
+          <a:p>
+            <a:pPr algn="l">
+              <a:spcBef>
+                <a:spcPts val="200"/>
+              </a:spcBef>
+              <a:spcAft>
+                <a:spcPts val="200"/>
+              </a:spcAft>
+              <a:defRPr sz="1400" b="0" i="0">
+                <a:solidFill>
+                  <a:srgbClr val="B0B0B0"/>
+                </a:solidFill>
+                <a:latin typeface="Inter"/>
+              </a:defRPr>
+            </a:pPr>
+            <a:r>
+              <a:t>5 min → 30s / post</a:t>
+            </a:r>
+          </a:p>
+        </p:txBody>
+      </p:sp>
+      <p:sp>
+        <p:nvSpPr>
+          <p:cNvPr id="9" name="TextBox 8"/>
+          <p:cNvSpPr txBox="1"/>
+          <p:nvPr/>
+        </p:nvSpPr>
+        <p:spPr>
+          <a:xfrm>
+            <a:off x="640080" y="3017520"/>
+            <a:ext cx="1097280" cy="274320"/>
+          </a:xfrm>
+          <a:prstGeom prst="rect">
+            <a:avLst/>
+          </a:prstGeom>
+          <a:noFill/>
+        </p:spPr>
+        <p:txBody>
+          <a:bodyPr wrap="square"/>
+          <a:lstStyle/>
+          <a:p>
+            <a:pPr algn="l">
+              <a:spcBef>
+                <a:spcPts val="200"/>
+              </a:spcBef>
+              <a:spcAft>
+                <a:spcPts val="200"/>
+              </a:spcAft>
+              <a:defRPr sz="1400" b="1" i="0">
+                <a:solidFill>
+                  <a:srgbClr val="00E676"/>
+                </a:solidFill>
+                <a:latin typeface="Inter"/>
+              </a:defRPr>
+            </a:pPr>
+            <a:r>
+              <a:t>VOLUME</a:t>
+            </a:r>
+          </a:p>
+        </p:txBody>
+      </p:sp>
+      <p:sp>
+        <p:nvSpPr>
+          <p:cNvPr id="10" name="TextBox 9"/>
+          <p:cNvSpPr txBox="1"/>
+          <p:nvPr/>
+        </p:nvSpPr>
+        <p:spPr>
+          <a:xfrm>
+            <a:off x="1828800" y="2926079"/>
+            <a:ext cx="1645920" cy="457200"/>
+          </a:xfrm>
+          <a:prstGeom prst="rect">
+            <a:avLst/>
+          </a:prstGeom>
+          <a:noFill/>
+        </p:spPr>
+        <p:txBody>
+          <a:bodyPr wrap="square"/>
+          <a:lstStyle/>
+          <a:p>
+            <a:pPr algn="ctr">
+              <a:spcBef>
+                <a:spcPts val="200"/>
+              </a:spcBef>
+              <a:spcAft>
+                <a:spcPts val="200"/>
+              </a:spcAft>
+              <a:defRPr sz="3600" b="1" i="0">
+                <a:solidFill>
+                  <a:srgbClr val="00E676"/>
+                </a:solidFill>
+                <a:latin typeface="Inter"/>
+              </a:defRPr>
+            </a:pPr>
+            <a:r>
+              <a:t>x200</a:t>
+            </a:r>
+          </a:p>
+        </p:txBody>
+      </p:sp>
+      <p:sp>
+        <p:nvSpPr>
+          <p:cNvPr id="11" name="TextBox 10"/>
+          <p:cNvSpPr txBox="1"/>
+          <p:nvPr/>
+        </p:nvSpPr>
+        <p:spPr>
+          <a:xfrm>
+            <a:off x="3566160" y="3035808"/>
+            <a:ext cx="2468880" cy="274320"/>
+          </a:xfrm>
+          <a:prstGeom prst="rect">
+            <a:avLst/>
+          </a:prstGeom>
+          <a:noFill/>
+        </p:spPr>
+        <p:txBody>
+          <a:bodyPr wrap="square"/>
+          <a:lstStyle/>
+          <a:p>
+            <a:pPr algn="l">
+              <a:spcBef>
+                <a:spcPts val="200"/>
+              </a:spcBef>
+              <a:spcAft>
+                <a:spcPts val="200"/>
+              </a:spcAft>
+              <a:defRPr sz="1400" b="0" i="0">
+                <a:solidFill>
+                  <a:srgbClr val="B0B0B0"/>
+                </a:solidFill>
+                <a:latin typeface="Inter"/>
+              </a:defRPr>
+            </a:pPr>
+            <a:r>
+              <a:t>60K posts/jour auto.</a:t>
+            </a:r>
+          </a:p>
+        </p:txBody>
+      </p:sp>
+      <p:sp>
+        <p:nvSpPr>
+          <p:cNvPr id="12" name="TextBox 11"/>
+          <p:cNvSpPr txBox="1"/>
+          <p:nvPr/>
+        </p:nvSpPr>
+        <p:spPr>
+          <a:xfrm>
+            <a:off x="640080" y="4069079"/>
+            <a:ext cx="1097280" cy="274320"/>
+          </a:xfrm>
+          <a:prstGeom prst="rect">
+            <a:avLst/>
+          </a:prstGeom>
+          <a:noFill/>
+        </p:spPr>
+        <p:txBody>
+          <a:bodyPr wrap="square"/>
+          <a:lstStyle/>
+          <a:p>
+            <a:pPr algn="l">
+              <a:spcBef>
+                <a:spcPts val="200"/>
+              </a:spcBef>
+              <a:spcAft>
+                <a:spcPts val="200"/>
+              </a:spcAft>
+              <a:defRPr sz="1400" b="1" i="0">
+                <a:solidFill>
+                  <a:srgbClr val="FFD600"/>
+                </a:solidFill>
+                <a:latin typeface="Inter"/>
+              </a:defRPr>
+            </a:pPr>
+            <a:r>
+              <a:t>RISQUE</a:t>
+            </a:r>
+          </a:p>
+        </p:txBody>
+      </p:sp>
+      <p:sp>
+        <p:nvSpPr>
+          <p:cNvPr id="13" name="TextBox 12"/>
+          <p:cNvSpPr txBox="1"/>
+          <p:nvPr/>
+        </p:nvSpPr>
+        <p:spPr>
+          <a:xfrm>
+            <a:off x="1828800" y="3977639"/>
+            <a:ext cx="1645920" cy="457200"/>
+          </a:xfrm>
+          <a:prstGeom prst="rect">
+            <a:avLst/>
+          </a:prstGeom>
+          <a:noFill/>
+        </p:spPr>
+        <p:txBody>
+          <a:bodyPr wrap="square"/>
+          <a:lstStyle/>
+          <a:p>
+            <a:pPr algn="ctr">
+              <a:spcBef>
+                <a:spcPts val="200"/>
+              </a:spcBef>
+              <a:spcAft>
+                <a:spcPts val="200"/>
+              </a:spcAft>
+              <a:defRPr sz="3600" b="1" i="0">
+                <a:solidFill>
+                  <a:srgbClr val="FFD600"/>
+                </a:solidFill>
+                <a:latin typeface="Inter"/>
+              </a:defRPr>
+            </a:pPr>
+            <a:r>
+              <a:t>-67%</a:t>
+            </a:r>
+          </a:p>
+        </p:txBody>
+      </p:sp>
+      <p:sp>
+        <p:nvSpPr>
+          <p:cNvPr id="14" name="TextBox 13"/>
+          <p:cNvSpPr txBox="1"/>
+          <p:nvPr/>
+        </p:nvSpPr>
+        <p:spPr>
+          <a:xfrm>
+            <a:off x="3566160" y="4087367"/>
+            <a:ext cx="2468880" cy="274320"/>
+          </a:xfrm>
+          <a:prstGeom prst="rect">
+            <a:avLst/>
+          </a:prstGeom>
+          <a:noFill/>
+        </p:spPr>
+        <p:txBody>
+          <a:bodyPr wrap="square"/>
+          <a:lstStyle/>
+          <a:p>
+            <a:pPr algn="l">
+              <a:spcBef>
+                <a:spcPts val="200"/>
+              </a:spcBef>
+              <a:spcAft>
+                <a:spcPts val="200"/>
+              </a:spcAft>
+              <a:defRPr sz="1400" b="0" i="0">
+                <a:solidFill>
+                  <a:srgbClr val="B0B0B0"/>
+                </a:solidFill>
+                <a:latin typeface="Inter"/>
+              </a:defRPr>
+            </a:pPr>
+            <a:r>
+              <a:t>faux positifs éliminés</a:t>
+            </a:r>
+          </a:p>
+        </p:txBody>
+      </p:sp>
+      <p:sp>
+        <p:nvSpPr>
+          <p:cNvPr id="15" name="TextBox 14"/>
+          <p:cNvSpPr txBox="1"/>
+          <p:nvPr/>
+        </p:nvSpPr>
+        <p:spPr>
+          <a:xfrm>
+            <a:off x="640080" y="5120640"/>
+            <a:ext cx="1097280" cy="274320"/>
+          </a:xfrm>
+          <a:prstGeom prst="rect">
+            <a:avLst/>
+          </a:prstGeom>
+          <a:noFill/>
+        </p:spPr>
+        <p:txBody>
+          <a:bodyPr wrap="square"/>
+          <a:lstStyle/>
+          <a:p>
+            <a:pPr algn="l">
+              <a:spcBef>
+                <a:spcPts val="200"/>
+              </a:spcBef>
+              <a:spcAft>
+                <a:spcPts val="200"/>
+              </a:spcAft>
+              <a:defRPr sz="1400" b="1" i="0">
+                <a:solidFill>
+                  <a:srgbClr val="FF1744"/>
+                </a:solidFill>
+                <a:latin typeface="Inter"/>
+              </a:defRPr>
+            </a:pPr>
+            <a:r>
+              <a:t>COÛT</a:t>
+            </a:r>
+          </a:p>
+        </p:txBody>
+      </p:sp>
+      <p:sp>
+        <p:nvSpPr>
+          <p:cNvPr id="16" name="TextBox 15"/>
+          <p:cNvSpPr txBox="1"/>
+          <p:nvPr/>
+        </p:nvSpPr>
+        <p:spPr>
+          <a:xfrm>
+            <a:off x="1828800" y="5029200"/>
+            <a:ext cx="1645920" cy="457200"/>
+          </a:xfrm>
+          <a:prstGeom prst="rect">
+            <a:avLst/>
+          </a:prstGeom>
+          <a:noFill/>
+        </p:spPr>
+        <p:txBody>
+          <a:bodyPr wrap="square"/>
+          <a:lstStyle/>
+          <a:p>
+            <a:pPr algn="ctr">
+              <a:spcBef>
+                <a:spcPts val="200"/>
+              </a:spcBef>
+              <a:spcAft>
+                <a:spcPts val="200"/>
+              </a:spcAft>
+              <a:defRPr sz="3600" b="1" i="0">
+                <a:solidFill>
+                  <a:srgbClr val="FF1744"/>
+                </a:solidFill>
+                <a:latin typeface="Inter"/>
+              </a:defRPr>
+            </a:pPr>
+            <a:r>
+              <a:t>≈ 0</a:t>
+            </a:r>
+          </a:p>
+        </p:txBody>
+      </p:sp>
+      <p:sp>
+        <p:nvSpPr>
+          <p:cNvPr id="17" name="TextBox 16"/>
+          <p:cNvSpPr txBox="1"/>
+          <p:nvPr/>
+        </p:nvSpPr>
+        <p:spPr>
+          <a:xfrm>
+            <a:off x="3566160" y="5138927"/>
+            <a:ext cx="2468880" cy="274320"/>
+          </a:xfrm>
+          <a:prstGeom prst="rect">
+            <a:avLst/>
+          </a:prstGeom>
+          <a:noFill/>
+        </p:spPr>
+        <p:txBody>
+          <a:bodyPr wrap="square"/>
+          <a:lstStyle/>
+          <a:p>
+            <a:pPr algn="l">
+              <a:spcBef>
+                <a:spcPts val="200"/>
+              </a:spcBef>
+              <a:spcAft>
+                <a:spcPts val="200"/>
+              </a:spcAft>
+              <a:defRPr sz="1400" b="0" i="0">
+                <a:solidFill>
+                  <a:srgbClr val="B0B0B0"/>
+                </a:solidFill>
+                <a:latin typeface="Inter"/>
+              </a:defRPr>
+            </a:pPr>
+            <a:r>
+              <a:t>0,0005 ct / post analysé</a:t>
+            </a:r>
+          </a:p>
+        </p:txBody>
+      </p:sp>
+      <p:sp>
+        <p:nvSpPr>
+          <p:cNvPr id="18" name="Rounded Rectangle 17"/>
+          <p:cNvSpPr/>
+          <p:nvPr/>
+        </p:nvSpPr>
+        <p:spPr>
+          <a:xfrm>
+            <a:off x="6583680" y="1280160"/>
+            <a:ext cx="4846320" cy="4937760"/>
           </a:xfrm>
           <a:prstGeom prst="roundRect">
             <a:avLst>
@@ -11479,14 +12137,14 @@
       </p:sp>
       <p:sp>
         <p:nvSpPr>
-          <p:cNvPr id="4" name="TextBox 3"/>
-          <p:cNvSpPr txBox="1"/>
-          <p:nvPr/>
-        </p:nvSpPr>
-        <p:spPr>
-          <a:xfrm>
-            <a:off x="548640" y="1554480"/>
-            <a:ext cx="2514600" cy="320040"/>
+          <p:cNvPr id="19" name="TextBox 18"/>
+          <p:cNvSpPr txBox="1"/>
+          <p:nvPr/>
+        </p:nvSpPr>
+        <p:spPr>
+          <a:xfrm>
+            <a:off x="6766560" y="1417320"/>
+            <a:ext cx="4480560" cy="320040"/>
           </a:xfrm>
           <a:prstGeom prst="rect">
             <a:avLst/>
@@ -11512,21 +12170,21 @@
               </a:defRPr>
             </a:pPr>
             <a:r>
-              <a:t>TEMPS</a:t>
-            </a:r>
-          </a:p>
-        </p:txBody>
-      </p:sp>
-      <p:sp>
-        <p:nvSpPr>
-          <p:cNvPr id="5" name="Rectangle 4"/>
+              <a:t>BUDGET PROJET</a:t>
+            </a:r>
+          </a:p>
+        </p:txBody>
+      </p:sp>
+      <p:sp>
+        <p:nvSpPr>
+          <p:cNvPr id="20" name="Rectangle 19"/>
           <p:cNvSpPr/>
           <p:nvPr/>
         </p:nvSpPr>
         <p:spPr>
           <a:xfrm>
-            <a:off x="731520" y="1965960"/>
-            <a:ext cx="2148840" cy="12700"/>
+            <a:off x="6858000" y="1828800"/>
+            <a:ext cx="4297680" cy="12700"/>
           </a:xfrm>
           <a:prstGeom prst="rect">
             <a:avLst/>
@@ -11562,65 +12220,25 @@
       </p:sp>
       <p:sp>
         <p:nvSpPr>
-          <p:cNvPr id="6" name="TextBox 5"/>
-          <p:cNvSpPr txBox="1"/>
-          <p:nvPr/>
-        </p:nvSpPr>
-        <p:spPr>
-          <a:xfrm>
-            <a:off x="548640" y="2103120"/>
-            <a:ext cx="2514600" cy="1097280"/>
-          </a:xfrm>
-          <a:prstGeom prst="rect">
-            <a:avLst/>
-          </a:prstGeom>
-          <a:noFill/>
-        </p:spPr>
-        <p:txBody>
-          <a:bodyPr wrap="square"/>
-          <a:lstStyle/>
-          <a:p>
-            <a:pPr algn="ctr">
-              <a:spcBef>
-                <a:spcPts val="200"/>
-              </a:spcBef>
-              <a:spcAft>
-                <a:spcPts val="200"/>
-              </a:spcAft>
-              <a:defRPr sz="5600" b="1" i="0">
-                <a:solidFill>
-                  <a:srgbClr val="00D4FF"/>
-                </a:solidFill>
-                <a:latin typeface="Inter"/>
-              </a:defRPr>
-            </a:pPr>
-            <a:r>
-              <a:t>10x</a:t>
-            </a:r>
-          </a:p>
-        </p:txBody>
-      </p:sp>
-      <p:sp>
-        <p:nvSpPr>
-          <p:cNvPr id="7" name="TextBox 6"/>
-          <p:cNvSpPr txBox="1"/>
-          <p:nvPr/>
-        </p:nvSpPr>
-        <p:spPr>
-          <a:xfrm>
-            <a:off x="640080" y="3291840"/>
-            <a:ext cx="2331720" cy="2286000"/>
-          </a:xfrm>
-          <a:prstGeom prst="rect">
-            <a:avLst/>
-          </a:prstGeom>
-          <a:noFill/>
-        </p:spPr>
-        <p:txBody>
-          <a:bodyPr wrap="square"/>
-          <a:lstStyle/>
-          <a:p>
-            <a:pPr algn="ctr">
+          <p:cNvPr id="21" name="TextBox 20"/>
+          <p:cNvSpPr txBox="1"/>
+          <p:nvPr/>
+        </p:nvSpPr>
+        <p:spPr>
+          <a:xfrm>
+            <a:off x="6949440" y="2011680"/>
+            <a:ext cx="2743200" cy="274320"/>
+          </a:xfrm>
+          <a:prstGeom prst="rect">
+            <a:avLst/>
+          </a:prstGeom>
+          <a:noFill/>
+        </p:spPr>
+        <p:txBody>
+          <a:bodyPr wrap="square"/>
+          <a:lstStyle/>
+          <a:p>
+            <a:pPr algn="l">
               <a:spcBef>
                 <a:spcPts val="200"/>
               </a:spcBef>
@@ -11629,17 +12247,238 @@
               </a:spcAft>
               <a:defRPr sz="1500" b="0" i="0">
                 <a:solidFill>
+                  <a:srgbClr val="E8E8E8"/>
+                </a:solidFill>
+                <a:latin typeface="Inter"/>
+              </a:defRPr>
+            </a:pPr>
+            <a:r>
+              <a:t>Ressources humaines</a:t>
+            </a:r>
+          </a:p>
+        </p:txBody>
+      </p:sp>
+      <p:sp>
+        <p:nvSpPr>
+          <p:cNvPr id="22" name="TextBox 21"/>
+          <p:cNvSpPr txBox="1"/>
+          <p:nvPr/>
+        </p:nvSpPr>
+        <p:spPr>
+          <a:xfrm>
+            <a:off x="9601200" y="2011680"/>
+            <a:ext cx="1645920" cy="274320"/>
+          </a:xfrm>
+          <a:prstGeom prst="rect">
+            <a:avLst/>
+          </a:prstGeom>
+          <a:noFill/>
+        </p:spPr>
+        <p:txBody>
+          <a:bodyPr wrap="square"/>
+          <a:lstStyle/>
+          <a:p>
+            <a:pPr algn="r">
+              <a:spcBef>
+                <a:spcPts val="200"/>
+              </a:spcBef>
+              <a:spcAft>
+                <a:spcPts val="200"/>
+              </a:spcAft>
+              <a:defRPr sz="1500" b="1" i="0">
+                <a:solidFill>
+                  <a:srgbClr val="E8E8E8"/>
+                </a:solidFill>
+                <a:latin typeface="Inter"/>
+              </a:defRPr>
+            </a:pPr>
+            <a:r>
+              <a:t>49 500 €</a:t>
+            </a:r>
+          </a:p>
+        </p:txBody>
+      </p:sp>
+      <p:sp>
+        <p:nvSpPr>
+          <p:cNvPr id="23" name="TextBox 22"/>
+          <p:cNvSpPr txBox="1"/>
+          <p:nvPr/>
+        </p:nvSpPr>
+        <p:spPr>
+          <a:xfrm>
+            <a:off x="7132320" y="2331720"/>
+            <a:ext cx="2743200" cy="274320"/>
+          </a:xfrm>
+          <a:prstGeom prst="rect">
+            <a:avLst/>
+          </a:prstGeom>
+          <a:noFill/>
+        </p:spPr>
+        <p:txBody>
+          <a:bodyPr wrap="square"/>
+          <a:lstStyle/>
+          <a:p>
+            <a:pPr algn="l">
+              <a:spcBef>
+                <a:spcPts val="200"/>
+              </a:spcBef>
+              <a:spcAft>
+                <a:spcPts val="200"/>
+              </a:spcAft>
+              <a:defRPr sz="1300" b="0" i="0">
+                <a:solidFill>
                   <a:srgbClr val="B0B0B0"/>
                 </a:solidFill>
                 <a:latin typeface="Inter"/>
               </a:defRPr>
             </a:pPr>
             <a:r>
-              <a:t>3-5 min/post (humain)</a:t>
-            </a:r>
-          </a:p>
-          <a:p>
-            <a:pPr algn="ctr">
+              <a:t>  Lead Technique (65 j)</a:t>
+            </a:r>
+          </a:p>
+        </p:txBody>
+      </p:sp>
+      <p:sp>
+        <p:nvSpPr>
+          <p:cNvPr id="24" name="TextBox 23"/>
+          <p:cNvSpPr txBox="1"/>
+          <p:nvPr/>
+        </p:nvSpPr>
+        <p:spPr>
+          <a:xfrm>
+            <a:off x="9601200" y="2331720"/>
+            <a:ext cx="1645920" cy="274320"/>
+          </a:xfrm>
+          <a:prstGeom prst="rect">
+            <a:avLst/>
+          </a:prstGeom>
+          <a:noFill/>
+        </p:spPr>
+        <p:txBody>
+          <a:bodyPr wrap="square"/>
+          <a:lstStyle/>
+          <a:p>
+            <a:pPr algn="r">
+              <a:spcBef>
+                <a:spcPts val="200"/>
+              </a:spcBef>
+              <a:spcAft>
+                <a:spcPts val="200"/>
+              </a:spcAft>
+              <a:defRPr sz="1300" b="1" i="0">
+                <a:solidFill>
+                  <a:srgbClr val="B0B0B0"/>
+                </a:solidFill>
+                <a:latin typeface="Inter"/>
+              </a:defRPr>
+            </a:pPr>
+            <a:r>
+              <a:t>29 250 €</a:t>
+            </a:r>
+          </a:p>
+        </p:txBody>
+      </p:sp>
+      <p:sp>
+        <p:nvSpPr>
+          <p:cNvPr id="25" name="TextBox 24"/>
+          <p:cNvSpPr txBox="1"/>
+          <p:nvPr/>
+        </p:nvSpPr>
+        <p:spPr>
+          <a:xfrm>
+            <a:off x="7132320" y="2651760"/>
+            <a:ext cx="2743200" cy="274320"/>
+          </a:xfrm>
+          <a:prstGeom prst="rect">
+            <a:avLst/>
+          </a:prstGeom>
+          <a:noFill/>
+        </p:spPr>
+        <p:txBody>
+          <a:bodyPr wrap="square"/>
+          <a:lstStyle/>
+          <a:p>
+            <a:pPr algn="l">
+              <a:spcBef>
+                <a:spcPts val="200"/>
+              </a:spcBef>
+              <a:spcAft>
+                <a:spcPts val="200"/>
+              </a:spcAft>
+              <a:defRPr sz="1300" b="0" i="0">
+                <a:solidFill>
+                  <a:srgbClr val="B0B0B0"/>
+                </a:solidFill>
+                <a:latin typeface="Inter"/>
+              </a:defRPr>
+            </a:pPr>
+            <a:r>
+              <a:t>  Validation ML (45 j)</a:t>
+            </a:r>
+          </a:p>
+        </p:txBody>
+      </p:sp>
+      <p:sp>
+        <p:nvSpPr>
+          <p:cNvPr id="26" name="TextBox 25"/>
+          <p:cNvSpPr txBox="1"/>
+          <p:nvPr/>
+        </p:nvSpPr>
+        <p:spPr>
+          <a:xfrm>
+            <a:off x="9601200" y="2651760"/>
+            <a:ext cx="1645920" cy="274320"/>
+          </a:xfrm>
+          <a:prstGeom prst="rect">
+            <a:avLst/>
+          </a:prstGeom>
+          <a:noFill/>
+        </p:spPr>
+        <p:txBody>
+          <a:bodyPr wrap="square"/>
+          <a:lstStyle/>
+          <a:p>
+            <a:pPr algn="r">
+              <a:spcBef>
+                <a:spcPts val="200"/>
+              </a:spcBef>
+              <a:spcAft>
+                <a:spcPts val="200"/>
+              </a:spcAft>
+              <a:defRPr sz="1300" b="1" i="0">
+                <a:solidFill>
+                  <a:srgbClr val="B0B0B0"/>
+                </a:solidFill>
+                <a:latin typeface="Inter"/>
+              </a:defRPr>
+            </a:pPr>
+            <a:r>
+              <a:t>20 250 €</a:t>
+            </a:r>
+          </a:p>
+        </p:txBody>
+      </p:sp>
+      <p:sp>
+        <p:nvSpPr>
+          <p:cNvPr id="27" name="TextBox 26"/>
+          <p:cNvSpPr txBox="1"/>
+          <p:nvPr/>
+        </p:nvSpPr>
+        <p:spPr>
+          <a:xfrm>
+            <a:off x="6949440" y="2971800"/>
+            <a:ext cx="2743200" cy="274320"/>
+          </a:xfrm>
+          <a:prstGeom prst="rect">
+            <a:avLst/>
+          </a:prstGeom>
+          <a:noFill/>
+        </p:spPr>
+        <p:txBody>
+          <a:bodyPr wrap="square"/>
+          <a:lstStyle/>
+          <a:p>
+            <a:pPr algn="l">
               <a:spcBef>
                 <a:spcPts val="200"/>
               </a:spcBef>
@@ -11648,17 +12487,78 @@
               </a:spcAft>
               <a:defRPr sz="1500" b="0" i="0">
                 <a:solidFill>
-                  <a:srgbClr val="B0B0B0"/>
-                </a:solidFill>
-                <a:latin typeface="Inter"/>
-              </a:defRPr>
-            </a:pPr>
-            <a:r>
-              <a:t>1,5 ms + 30s validation</a:t>
-            </a:r>
-          </a:p>
-          <a:p>
-            <a:pPr algn="ctr">
+                  <a:srgbClr val="E8E8E8"/>
+                </a:solidFill>
+                <a:latin typeface="Inter"/>
+              </a:defRPr>
+            </a:pPr>
+            <a:r>
+              <a:t>Infrastructure</a:t>
+            </a:r>
+          </a:p>
+        </p:txBody>
+      </p:sp>
+      <p:sp>
+        <p:nvSpPr>
+          <p:cNvPr id="28" name="TextBox 27"/>
+          <p:cNvSpPr txBox="1"/>
+          <p:nvPr/>
+        </p:nvSpPr>
+        <p:spPr>
+          <a:xfrm>
+            <a:off x="9601200" y="2971800"/>
+            <a:ext cx="1645920" cy="274320"/>
+          </a:xfrm>
+          <a:prstGeom prst="rect">
+            <a:avLst/>
+          </a:prstGeom>
+          <a:noFill/>
+        </p:spPr>
+        <p:txBody>
+          <a:bodyPr wrap="square"/>
+          <a:lstStyle/>
+          <a:p>
+            <a:pPr algn="r">
+              <a:spcBef>
+                <a:spcPts val="200"/>
+              </a:spcBef>
+              <a:spcAft>
+                <a:spcPts val="200"/>
+              </a:spcAft>
+              <a:defRPr sz="1500" b="1" i="0">
+                <a:solidFill>
+                  <a:srgbClr val="E8E8E8"/>
+                </a:solidFill>
+                <a:latin typeface="Inter"/>
+              </a:defRPr>
+            </a:pPr>
+            <a:r>
+              <a:t>0 €</a:t>
+            </a:r>
+          </a:p>
+        </p:txBody>
+      </p:sp>
+      <p:sp>
+        <p:nvSpPr>
+          <p:cNvPr id="29" name="TextBox 28"/>
+          <p:cNvSpPr txBox="1"/>
+          <p:nvPr/>
+        </p:nvSpPr>
+        <p:spPr>
+          <a:xfrm>
+            <a:off x="6949440" y="3291840"/>
+            <a:ext cx="2743200" cy="274320"/>
+          </a:xfrm>
+          <a:prstGeom prst="rect">
+            <a:avLst/>
+          </a:prstGeom>
+          <a:noFill/>
+        </p:spPr>
+        <p:txBody>
+          <a:bodyPr wrap="square"/>
+          <a:lstStyle/>
+          <a:p>
+            <a:pPr algn="l">
               <a:spcBef>
                 <a:spcPts val="200"/>
               </a:spcBef>
@@ -11667,40 +12567,156 @@
               </a:spcAft>
               <a:defRPr sz="1500" b="0" i="0">
                 <a:solidFill>
-                  <a:srgbClr val="B0B0B0"/>
-                </a:solidFill>
-                <a:latin typeface="Inter"/>
-              </a:defRPr>
-            </a:pPr>
-            <a:r>
-              <a:t>= x10 productivité</a:t>
-            </a:r>
-          </a:p>
-        </p:txBody>
-      </p:sp>
-      <p:sp>
-        <p:nvSpPr>
-          <p:cNvPr id="8" name="Rounded Rectangle 7"/>
+                  <a:srgbClr val="E8E8E8"/>
+                </a:solidFill>
+                <a:latin typeface="Inter"/>
+              </a:defRPr>
+            </a:pPr>
+            <a:r>
+              <a:t>Licences / outils</a:t>
+            </a:r>
+          </a:p>
+        </p:txBody>
+      </p:sp>
+      <p:sp>
+        <p:nvSpPr>
+          <p:cNvPr id="30" name="TextBox 29"/>
+          <p:cNvSpPr txBox="1"/>
+          <p:nvPr/>
+        </p:nvSpPr>
+        <p:spPr>
+          <a:xfrm>
+            <a:off x="9601200" y="3291840"/>
+            <a:ext cx="1645920" cy="274320"/>
+          </a:xfrm>
+          <a:prstGeom prst="rect">
+            <a:avLst/>
+          </a:prstGeom>
+          <a:noFill/>
+        </p:spPr>
+        <p:txBody>
+          <a:bodyPr wrap="square"/>
+          <a:lstStyle/>
+          <a:p>
+            <a:pPr algn="r">
+              <a:spcBef>
+                <a:spcPts val="200"/>
+              </a:spcBef>
+              <a:spcAft>
+                <a:spcPts val="200"/>
+              </a:spcAft>
+              <a:defRPr sz="1500" b="1" i="0">
+                <a:solidFill>
+                  <a:srgbClr val="E8E8E8"/>
+                </a:solidFill>
+                <a:latin typeface="Inter"/>
+              </a:defRPr>
+            </a:pPr>
+            <a:r>
+              <a:t>0 €</a:t>
+            </a:r>
+          </a:p>
+        </p:txBody>
+      </p:sp>
+      <p:sp>
+        <p:nvSpPr>
+          <p:cNvPr id="31" name="TextBox 30"/>
+          <p:cNvSpPr txBox="1"/>
+          <p:nvPr/>
+        </p:nvSpPr>
+        <p:spPr>
+          <a:xfrm>
+            <a:off x="6949440" y="3611880"/>
+            <a:ext cx="2743200" cy="274320"/>
+          </a:xfrm>
+          <a:prstGeom prst="rect">
+            <a:avLst/>
+          </a:prstGeom>
+          <a:noFill/>
+        </p:spPr>
+        <p:txBody>
+          <a:bodyPr wrap="square"/>
+          <a:lstStyle/>
+          <a:p>
+            <a:pPr algn="l">
+              <a:spcBef>
+                <a:spcPts val="200"/>
+              </a:spcBef>
+              <a:spcAft>
+                <a:spcPts val="200"/>
+              </a:spcAft>
+              <a:defRPr sz="1500" b="0" i="0">
+                <a:solidFill>
+                  <a:srgbClr val="E8E8E8"/>
+                </a:solidFill>
+                <a:latin typeface="Inter"/>
+              </a:defRPr>
+            </a:pPr>
+            <a:r>
+              <a:t>Annotation gold set</a:t>
+            </a:r>
+          </a:p>
+        </p:txBody>
+      </p:sp>
+      <p:sp>
+        <p:nvSpPr>
+          <p:cNvPr id="32" name="TextBox 31"/>
+          <p:cNvSpPr txBox="1"/>
+          <p:nvPr/>
+        </p:nvSpPr>
+        <p:spPr>
+          <a:xfrm>
+            <a:off x="9601200" y="3611880"/>
+            <a:ext cx="1645920" cy="274320"/>
+          </a:xfrm>
+          <a:prstGeom prst="rect">
+            <a:avLst/>
+          </a:prstGeom>
+          <a:noFill/>
+        </p:spPr>
+        <p:txBody>
+          <a:bodyPr wrap="square"/>
+          <a:lstStyle/>
+          <a:p>
+            <a:pPr algn="r">
+              <a:spcBef>
+                <a:spcPts val="200"/>
+              </a:spcBef>
+              <a:spcAft>
+                <a:spcPts val="200"/>
+              </a:spcAft>
+              <a:defRPr sz="1500" b="1" i="0">
+                <a:solidFill>
+                  <a:srgbClr val="E8E8E8"/>
+                </a:solidFill>
+                <a:latin typeface="Inter"/>
+              </a:defRPr>
+            </a:pPr>
+            <a:r>
+              <a:t>750 €</a:t>
+            </a:r>
+          </a:p>
+        </p:txBody>
+      </p:sp>
+      <p:sp>
+        <p:nvSpPr>
+          <p:cNvPr id="33" name="Rectangle 32"/>
           <p:cNvSpPr/>
           <p:nvPr/>
         </p:nvSpPr>
         <p:spPr>
           <a:xfrm>
-            <a:off x="3337560" y="1371600"/>
-            <a:ext cx="2697480" cy="4389120"/>
-          </a:xfrm>
-          <a:prstGeom prst="roundRect">
-            <a:avLst>
-              <a:gd name="adj" fmla="val 15000"/>
-            </a:avLst>
+            <a:off x="6949440" y="3977640"/>
+            <a:ext cx="4114800" cy="25400"/>
+          </a:xfrm>
+          <a:prstGeom prst="rect">
+            <a:avLst/>
           </a:prstGeom>
           <a:solidFill>
-            <a:srgbClr val="1A1F2E"/>
+            <a:srgbClr val="00D4FF"/>
           </a:solidFill>
-          <a:ln w="19050">
-            <a:solidFill>
-              <a:srgbClr val="00E676"/>
-            </a:solidFill>
+          <a:ln>
+            <a:noFill/>
           </a:ln>
         </p:spPr>
         <p:style>
@@ -11727,54 +12743,94 @@
       </p:sp>
       <p:sp>
         <p:nvSpPr>
-          <p:cNvPr id="9" name="TextBox 8"/>
-          <p:cNvSpPr txBox="1"/>
-          <p:nvPr/>
-        </p:nvSpPr>
-        <p:spPr>
-          <a:xfrm>
-            <a:off x="3429000" y="1554480"/>
-            <a:ext cx="2514600" cy="320040"/>
-          </a:xfrm>
-          <a:prstGeom prst="rect">
-            <a:avLst/>
-          </a:prstGeom>
-          <a:noFill/>
-        </p:spPr>
-        <p:txBody>
-          <a:bodyPr wrap="square"/>
-          <a:lstStyle/>
-          <a:p>
-            <a:pPr algn="ctr">
-              <a:spcBef>
-                <a:spcPts val="200"/>
-              </a:spcBef>
-              <a:spcAft>
-                <a:spcPts val="200"/>
-              </a:spcAft>
-              <a:defRPr sz="1600" b="1" i="0">
-                <a:solidFill>
-                  <a:srgbClr val="00E676"/>
-                </a:solidFill>
-                <a:latin typeface="Inter"/>
-              </a:defRPr>
-            </a:pPr>
-            <a:r>
-              <a:t>VOLUME</a:t>
-            </a:r>
-          </a:p>
-        </p:txBody>
-      </p:sp>
-      <p:sp>
-        <p:nvSpPr>
-          <p:cNvPr id="10" name="Rectangle 9"/>
+          <p:cNvPr id="34" name="TextBox 33"/>
+          <p:cNvSpPr txBox="1"/>
+          <p:nvPr/>
+        </p:nvSpPr>
+        <p:spPr>
+          <a:xfrm>
+            <a:off x="6949440" y="4114800"/>
+            <a:ext cx="2743200" cy="320040"/>
+          </a:xfrm>
+          <a:prstGeom prst="rect">
+            <a:avLst/>
+          </a:prstGeom>
+          <a:noFill/>
+        </p:spPr>
+        <p:txBody>
+          <a:bodyPr wrap="square"/>
+          <a:lstStyle/>
+          <a:p>
+            <a:pPr algn="l">
+              <a:spcBef>
+                <a:spcPts val="200"/>
+              </a:spcBef>
+              <a:spcAft>
+                <a:spcPts val="200"/>
+              </a:spcAft>
+              <a:defRPr sz="1700" b="1" i="0">
+                <a:solidFill>
+                  <a:srgbClr val="00D4FF"/>
+                </a:solidFill>
+                <a:latin typeface="Inter"/>
+              </a:defRPr>
+            </a:pPr>
+            <a:r>
+              <a:t>TOTAL PROJET</a:t>
+            </a:r>
+          </a:p>
+        </p:txBody>
+      </p:sp>
+      <p:sp>
+        <p:nvSpPr>
+          <p:cNvPr id="35" name="TextBox 34"/>
+          <p:cNvSpPr txBox="1"/>
+          <p:nvPr/>
+        </p:nvSpPr>
+        <p:spPr>
+          <a:xfrm>
+            <a:off x="9601200" y="4114800"/>
+            <a:ext cx="1645920" cy="320040"/>
+          </a:xfrm>
+          <a:prstGeom prst="rect">
+            <a:avLst/>
+          </a:prstGeom>
+          <a:noFill/>
+        </p:spPr>
+        <p:txBody>
+          <a:bodyPr wrap="square"/>
+          <a:lstStyle/>
+          <a:p>
+            <a:pPr algn="r">
+              <a:spcBef>
+                <a:spcPts val="200"/>
+              </a:spcBef>
+              <a:spcAft>
+                <a:spcPts val="200"/>
+              </a:spcAft>
+              <a:defRPr sz="1700" b="1" i="0">
+                <a:solidFill>
+                  <a:srgbClr val="00D4FF"/>
+                </a:solidFill>
+                <a:latin typeface="Inter"/>
+              </a:defRPr>
+            </a:pPr>
+            <a:r>
+              <a:t>50 250 €</a:t>
+            </a:r>
+          </a:p>
+        </p:txBody>
+      </p:sp>
+      <p:sp>
+        <p:nvSpPr>
+          <p:cNvPr id="36" name="Rectangle 35"/>
           <p:cNvSpPr/>
           <p:nvPr/>
         </p:nvSpPr>
         <p:spPr>
           <a:xfrm>
-            <a:off x="3611879" y="1965960"/>
-            <a:ext cx="2148840" cy="12700"/>
+            <a:off x="6949440" y="4617720"/>
+            <a:ext cx="4114800" cy="12700"/>
           </a:xfrm>
           <a:prstGeom prst="rect">
             <a:avLst/>
@@ -11810,14 +12866,153 @@
       </p:sp>
       <p:sp>
         <p:nvSpPr>
-          <p:cNvPr id="11" name="TextBox 10"/>
-          <p:cNvSpPr txBox="1"/>
-          <p:nvPr/>
-        </p:nvSpPr>
-        <p:spPr>
-          <a:xfrm>
-            <a:off x="3429000" y="2103120"/>
-            <a:ext cx="2514600" cy="1097280"/>
+          <p:cNvPr id="37" name="TextBox 36"/>
+          <p:cNvSpPr txBox="1"/>
+          <p:nvPr/>
+        </p:nvSpPr>
+        <p:spPr>
+          <a:xfrm>
+            <a:off x="6949440" y="4754880"/>
+            <a:ext cx="2743200" cy="274320"/>
+          </a:xfrm>
+          <a:prstGeom prst="rect">
+            <a:avLst/>
+          </a:prstGeom>
+          <a:noFill/>
+        </p:spPr>
+        <p:txBody>
+          <a:bodyPr wrap="square"/>
+          <a:lstStyle/>
+          <a:p>
+            <a:pPr algn="l">
+              <a:spcBef>
+                <a:spcPts val="200"/>
+              </a:spcBef>
+              <a:spcAft>
+                <a:spcPts val="200"/>
+              </a:spcAft>
+              <a:defRPr sz="1400" b="0" i="0">
+                <a:solidFill>
+                  <a:srgbClr val="00E676"/>
+                </a:solidFill>
+                <a:latin typeface="Inter"/>
+              </a:defRPr>
+            </a:pPr>
+            <a:r>
+              <a:t>Exploitation mensuelle</a:t>
+            </a:r>
+          </a:p>
+        </p:txBody>
+      </p:sp>
+      <p:sp>
+        <p:nvSpPr>
+          <p:cNvPr id="38" name="TextBox 37"/>
+          <p:cNvSpPr txBox="1"/>
+          <p:nvPr/>
+        </p:nvSpPr>
+        <p:spPr>
+          <a:xfrm>
+            <a:off x="9601200" y="4754880"/>
+            <a:ext cx="1645920" cy="274320"/>
+          </a:xfrm>
+          <a:prstGeom prst="rect">
+            <a:avLst/>
+          </a:prstGeom>
+          <a:noFill/>
+        </p:spPr>
+        <p:txBody>
+          <a:bodyPr wrap="square"/>
+          <a:lstStyle/>
+          <a:p>
+            <a:pPr algn="r">
+              <a:spcBef>
+                <a:spcPts val="200"/>
+              </a:spcBef>
+              <a:spcAft>
+                <a:spcPts val="200"/>
+              </a:spcAft>
+              <a:defRPr sz="1400" b="1" i="0">
+                <a:solidFill>
+                  <a:srgbClr val="00E676"/>
+                </a:solidFill>
+                <a:latin typeface="Inter"/>
+              </a:defRPr>
+            </a:pPr>
+            <a:r>
+              <a:t>~930 €/mois</a:t>
+            </a:r>
+          </a:p>
+        </p:txBody>
+      </p:sp>
+      <p:sp>
+        <p:nvSpPr>
+          <p:cNvPr id="39" name="TextBox 38"/>
+          <p:cNvSpPr txBox="1"/>
+          <p:nvPr/>
+        </p:nvSpPr>
+        <p:spPr>
+          <a:xfrm>
+            <a:off x="6949440" y="5074920"/>
+            <a:ext cx="4114800" cy="457200"/>
+          </a:xfrm>
+          <a:prstGeom prst="rect">
+            <a:avLst/>
+          </a:prstGeom>
+          <a:noFill/>
+        </p:spPr>
+        <p:txBody>
+          <a:bodyPr wrap="square"/>
+          <a:lstStyle/>
+          <a:p>
+            <a:pPr algn="l">
+              <a:spcBef>
+                <a:spcPts val="200"/>
+              </a:spcBef>
+              <a:spcAft>
+                <a:spcPts val="200"/>
+              </a:spcAft>
+              <a:defRPr sz="1200" b="0" i="1">
+                <a:solidFill>
+                  <a:srgbClr val="606060"/>
+                </a:solidFill>
+                <a:latin typeface="Inter"/>
+              </a:defRPr>
+            </a:pPr>
+            <a:r>
+              <a:t>100% open source</a:t>
+            </a:r>
+          </a:p>
+          <a:p>
+            <a:pPr algn="l">
+              <a:spcBef>
+                <a:spcPts val="200"/>
+              </a:spcBef>
+              <a:spcAft>
+                <a:spcPts val="200"/>
+              </a:spcAft>
+              <a:defRPr sz="1200" b="0" i="1">
+                <a:solidFill>
+                  <a:srgbClr val="606060"/>
+                </a:solidFill>
+                <a:latin typeface="Inter"/>
+              </a:defRPr>
+            </a:pPr>
+            <a:r>
+              <a:t>Aucun coût de licence</a:t>
+            </a:r>
+          </a:p>
+        </p:txBody>
+      </p:sp>
+      <p:sp>
+        <p:nvSpPr>
+          <p:cNvPr id="40" name="TextBox 39"/>
+          <p:cNvSpPr txBox="1"/>
+          <p:nvPr/>
+        </p:nvSpPr>
+        <p:spPr>
+          <a:xfrm>
+            <a:off x="365760" y="6263640"/>
+            <a:ext cx="11247120" cy="274320"/>
           </a:xfrm>
           <a:prstGeom prst="rect">
             <a:avLst/>
@@ -11835,621 +13030,7 @@
               <a:spcAft>
                 <a:spcPts val="200"/>
               </a:spcAft>
-              <a:defRPr sz="5600" b="1" i="0">
-                <a:solidFill>
-                  <a:srgbClr val="00E676"/>
-                </a:solidFill>
-                <a:latin typeface="Inter"/>
-              </a:defRPr>
-            </a:pPr>
-            <a:r>
-              <a:t>200x</a:t>
-            </a:r>
-          </a:p>
-        </p:txBody>
-      </p:sp>
-      <p:sp>
-        <p:nvSpPr>
-          <p:cNvPr id="12" name="TextBox 11"/>
-          <p:cNvSpPr txBox="1"/>
-          <p:nvPr/>
-        </p:nvSpPr>
-        <p:spPr>
-          <a:xfrm>
-            <a:off x="3520440" y="3291840"/>
-            <a:ext cx="2331720" cy="2286000"/>
-          </a:xfrm>
-          <a:prstGeom prst="rect">
-            <a:avLst/>
-          </a:prstGeom>
-          <a:noFill/>
-        </p:spPr>
-        <p:txBody>
-          <a:bodyPr wrap="square"/>
-          <a:lstStyle/>
-          <a:p>
-            <a:pPr algn="ctr">
-              <a:spcBef>
-                <a:spcPts val="200"/>
-              </a:spcBef>
-              <a:spcAft>
-                <a:spcPts val="200"/>
-              </a:spcAft>
-              <a:defRPr sz="1500" b="0" i="0">
-                <a:solidFill>
-                  <a:srgbClr val="B0B0B0"/>
-                </a:solidFill>
-                <a:latin typeface="Inter"/>
-              </a:defRPr>
-            </a:pPr>
-            <a:r>
-              <a:t>60 000 posts/jour traités</a:t>
-            </a:r>
-          </a:p>
-          <a:p>
-            <a:pPr algn="ctr">
-              <a:spcBef>
-                <a:spcPts val="200"/>
-              </a:spcBef>
-              <a:spcAft>
-                <a:spcPts val="200"/>
-              </a:spcAft>
-              <a:defRPr sz="1500" b="0" i="0">
-                <a:solidFill>
-                  <a:srgbClr val="B0B0B0"/>
-                </a:solidFill>
-                <a:latin typeface="Inter"/>
-              </a:defRPr>
-            </a:pPr>
-            <a:r>
-              <a:t>vs 200-300/jour (humain)</a:t>
-            </a:r>
-          </a:p>
-          <a:p>
-            <a:pPr algn="ctr">
-              <a:spcBef>
-                <a:spcPts val="200"/>
-              </a:spcBef>
-              <a:spcAft>
-                <a:spcPts val="200"/>
-              </a:spcAft>
-              <a:defRPr sz="1500" b="0" i="0">
-                <a:solidFill>
-                  <a:srgbClr val="B0B0B0"/>
-                </a:solidFill>
-                <a:latin typeface="Inter"/>
-              </a:defRPr>
-            </a:pPr>
-            <a:r>
-              <a:t>= couverture totale</a:t>
-            </a:r>
-          </a:p>
-        </p:txBody>
-      </p:sp>
-      <p:sp>
-        <p:nvSpPr>
-          <p:cNvPr id="13" name="Rounded Rectangle 12"/>
-          <p:cNvSpPr/>
-          <p:nvPr/>
-        </p:nvSpPr>
-        <p:spPr>
-          <a:xfrm>
-            <a:off x="6217920" y="1371600"/>
-            <a:ext cx="2697480" cy="4389120"/>
-          </a:xfrm>
-          <a:prstGeom prst="roundRect">
-            <a:avLst>
-              <a:gd name="adj" fmla="val 15000"/>
-            </a:avLst>
-          </a:prstGeom>
-          <a:solidFill>
-            <a:srgbClr val="1A1F2E"/>
-          </a:solidFill>
-          <a:ln w="19050">
-            <a:solidFill>
-              <a:srgbClr val="FFD600"/>
-            </a:solidFill>
-          </a:ln>
-        </p:spPr>
-        <p:style>
-          <a:lnRef idx="1">
-            <a:schemeClr val="accent1"/>
-          </a:lnRef>
-          <a:fillRef idx="3">
-            <a:schemeClr val="accent1"/>
-          </a:fillRef>
-          <a:effectRef idx="2">
-            <a:schemeClr val="accent1"/>
-          </a:effectRef>
-          <a:fontRef idx="minor">
-            <a:schemeClr val="lt1"/>
-          </a:fontRef>
-        </p:style>
-        <p:txBody>
-          <a:bodyPr rtlCol="0" anchor="ctr"/>
-          <a:lstStyle/>
-          <a:p>
-            <a:pPr algn="ctr"/>
-          </a:p>
-        </p:txBody>
-      </p:sp>
-      <p:sp>
-        <p:nvSpPr>
-          <p:cNvPr id="14" name="TextBox 13"/>
-          <p:cNvSpPr txBox="1"/>
-          <p:nvPr/>
-        </p:nvSpPr>
-        <p:spPr>
-          <a:xfrm>
-            <a:off x="6309359" y="1554480"/>
-            <a:ext cx="2514600" cy="320040"/>
-          </a:xfrm>
-          <a:prstGeom prst="rect">
-            <a:avLst/>
-          </a:prstGeom>
-          <a:noFill/>
-        </p:spPr>
-        <p:txBody>
-          <a:bodyPr wrap="square"/>
-          <a:lstStyle/>
-          <a:p>
-            <a:pPr algn="ctr">
-              <a:spcBef>
-                <a:spcPts val="200"/>
-              </a:spcBef>
-              <a:spcAft>
-                <a:spcPts val="200"/>
-              </a:spcAft>
-              <a:defRPr sz="1600" b="1" i="0">
-                <a:solidFill>
-                  <a:srgbClr val="FFD600"/>
-                </a:solidFill>
-                <a:latin typeface="Inter"/>
-              </a:defRPr>
-            </a:pPr>
-            <a:r>
-              <a:t>RISQUE</a:t>
-            </a:r>
-          </a:p>
-        </p:txBody>
-      </p:sp>
-      <p:sp>
-        <p:nvSpPr>
-          <p:cNvPr id="15" name="Rectangle 14"/>
-          <p:cNvSpPr/>
-          <p:nvPr/>
-        </p:nvSpPr>
-        <p:spPr>
-          <a:xfrm>
-            <a:off x="6492240" y="1965960"/>
-            <a:ext cx="2148840" cy="12700"/>
-          </a:xfrm>
-          <a:prstGeom prst="rect">
-            <a:avLst/>
-          </a:prstGeom>
-          <a:solidFill>
-            <a:srgbClr val="2A2F3E"/>
-          </a:solidFill>
-          <a:ln>
-            <a:noFill/>
-          </a:ln>
-        </p:spPr>
-        <p:style>
-          <a:lnRef idx="1">
-            <a:schemeClr val="accent1"/>
-          </a:lnRef>
-          <a:fillRef idx="3">
-            <a:schemeClr val="accent1"/>
-          </a:fillRef>
-          <a:effectRef idx="2">
-            <a:schemeClr val="accent1"/>
-          </a:effectRef>
-          <a:fontRef idx="minor">
-            <a:schemeClr val="lt1"/>
-          </a:fontRef>
-        </p:style>
-        <p:txBody>
-          <a:bodyPr rtlCol="0" anchor="ctr"/>
-          <a:lstStyle/>
-          <a:p>
-            <a:pPr algn="ctr"/>
-          </a:p>
-        </p:txBody>
-      </p:sp>
-      <p:sp>
-        <p:nvSpPr>
-          <p:cNvPr id="16" name="TextBox 15"/>
-          <p:cNvSpPr txBox="1"/>
-          <p:nvPr/>
-        </p:nvSpPr>
-        <p:spPr>
-          <a:xfrm>
-            <a:off x="6309359" y="2103120"/>
-            <a:ext cx="2514600" cy="1097280"/>
-          </a:xfrm>
-          <a:prstGeom prst="rect">
-            <a:avLst/>
-          </a:prstGeom>
-          <a:noFill/>
-        </p:spPr>
-        <p:txBody>
-          <a:bodyPr wrap="square"/>
-          <a:lstStyle/>
-          <a:p>
-            <a:pPr algn="ctr">
-              <a:spcBef>
-                <a:spcPts val="200"/>
-              </a:spcBef>
-              <a:spcAft>
-                <a:spcPts val="200"/>
-              </a:spcAft>
-              <a:defRPr sz="5600" b="1" i="0">
-                <a:solidFill>
-                  <a:srgbClr val="FFD600"/>
-                </a:solidFill>
-                <a:latin typeface="Inter"/>
-              </a:defRPr>
-            </a:pPr>
-            <a:r>
-              <a:t>-67%</a:t>
-            </a:r>
-          </a:p>
-        </p:txBody>
-      </p:sp>
-      <p:sp>
-        <p:nvSpPr>
-          <p:cNvPr id="17" name="TextBox 16"/>
-          <p:cNvSpPr txBox="1"/>
-          <p:nvPr/>
-        </p:nvSpPr>
-        <p:spPr>
-          <a:xfrm>
-            <a:off x="6400800" y="3291840"/>
-            <a:ext cx="2331720" cy="2286000"/>
-          </a:xfrm>
-          <a:prstGeom prst="rect">
-            <a:avLst/>
-          </a:prstGeom>
-          <a:noFill/>
-        </p:spPr>
-        <p:txBody>
-          <a:bodyPr wrap="square"/>
-          <a:lstStyle/>
-          <a:p>
-            <a:pPr algn="ctr">
-              <a:spcBef>
-                <a:spcPts val="200"/>
-              </a:spcBef>
-              <a:spcAft>
-                <a:spcPts val="200"/>
-              </a:spcAft>
-              <a:defRPr sz="1500" b="0" i="0">
-                <a:solidFill>
-                  <a:srgbClr val="B0B0B0"/>
-                </a:solidFill>
-                <a:latin typeface="Inter"/>
-              </a:defRPr>
-            </a:pPr>
-            <a:r>
-              <a:t>AI Act + RGPD intégrés</a:t>
-            </a:r>
-          </a:p>
-          <a:p>
-            <a:pPr algn="ctr">
-              <a:spcBef>
-                <a:spcPts val="200"/>
-              </a:spcBef>
-              <a:spcAft>
-                <a:spcPts val="200"/>
-              </a:spcAft>
-              <a:defRPr sz="1500" b="0" i="0">
-                <a:solidFill>
-                  <a:srgbClr val="B0B0B0"/>
-                </a:solidFill>
-                <a:latin typeface="Inter"/>
-              </a:defRPr>
-            </a:pPr>
-            <a:r>
-              <a:t>FP réduits de 67 %</a:t>
-            </a:r>
-          </a:p>
-          <a:p>
-            <a:pPr algn="ctr">
-              <a:spcBef>
-                <a:spcPts val="200"/>
-              </a:spcBef>
-              <a:spcAft>
-                <a:spcPts val="200"/>
-              </a:spcAft>
-              <a:defRPr sz="1500" b="0" i="0">
-                <a:solidFill>
-                  <a:srgbClr val="B0B0B0"/>
-                </a:solidFill>
-                <a:latin typeface="Inter"/>
-              </a:defRPr>
-            </a:pPr>
-            <a:r>
-              <a:t>= confiance préservée</a:t>
-            </a:r>
-          </a:p>
-        </p:txBody>
-      </p:sp>
-      <p:sp>
-        <p:nvSpPr>
-          <p:cNvPr id="18" name="Rounded Rectangle 17"/>
-          <p:cNvSpPr/>
-          <p:nvPr/>
-        </p:nvSpPr>
-        <p:spPr>
-          <a:xfrm>
-            <a:off x="9098280" y="1371600"/>
-            <a:ext cx="2697480" cy="4389120"/>
-          </a:xfrm>
-          <a:prstGeom prst="roundRect">
-            <a:avLst>
-              <a:gd name="adj" fmla="val 15000"/>
-            </a:avLst>
-          </a:prstGeom>
-          <a:solidFill>
-            <a:srgbClr val="1A1F2E"/>
-          </a:solidFill>
-          <a:ln w="19050">
-            <a:solidFill>
-              <a:srgbClr val="FF1744"/>
-            </a:solidFill>
-          </a:ln>
-        </p:spPr>
-        <p:style>
-          <a:lnRef idx="1">
-            <a:schemeClr val="accent1"/>
-          </a:lnRef>
-          <a:fillRef idx="3">
-            <a:schemeClr val="accent1"/>
-          </a:fillRef>
-          <a:effectRef idx="2">
-            <a:schemeClr val="accent1"/>
-          </a:effectRef>
-          <a:fontRef idx="minor">
-            <a:schemeClr val="lt1"/>
-          </a:fontRef>
-        </p:style>
-        <p:txBody>
-          <a:bodyPr rtlCol="0" anchor="ctr"/>
-          <a:lstStyle/>
-          <a:p>
-            <a:pPr algn="ctr"/>
-          </a:p>
-        </p:txBody>
-      </p:sp>
-      <p:sp>
-        <p:nvSpPr>
-          <p:cNvPr id="19" name="TextBox 18"/>
-          <p:cNvSpPr txBox="1"/>
-          <p:nvPr/>
-        </p:nvSpPr>
-        <p:spPr>
-          <a:xfrm>
-            <a:off x="9189719" y="1554480"/>
-            <a:ext cx="2514600" cy="320040"/>
-          </a:xfrm>
-          <a:prstGeom prst="rect">
-            <a:avLst/>
-          </a:prstGeom>
-          <a:noFill/>
-        </p:spPr>
-        <p:txBody>
-          <a:bodyPr wrap="square"/>
-          <a:lstStyle/>
-          <a:p>
-            <a:pPr algn="ctr">
-              <a:spcBef>
-                <a:spcPts val="200"/>
-              </a:spcBef>
-              <a:spcAft>
-                <a:spcPts val="200"/>
-              </a:spcAft>
-              <a:defRPr sz="1600" b="1" i="0">
-                <a:solidFill>
-                  <a:srgbClr val="FF1744"/>
-                </a:solidFill>
-                <a:latin typeface="Inter"/>
-              </a:defRPr>
-            </a:pPr>
-            <a:r>
-              <a:t>COÛT</a:t>
-            </a:r>
-          </a:p>
-        </p:txBody>
-      </p:sp>
-      <p:sp>
-        <p:nvSpPr>
-          <p:cNvPr id="20" name="Rectangle 19"/>
-          <p:cNvSpPr/>
-          <p:nvPr/>
-        </p:nvSpPr>
-        <p:spPr>
-          <a:xfrm>
-            <a:off x="9372600" y="1965960"/>
-            <a:ext cx="2148840" cy="12700"/>
-          </a:xfrm>
-          <a:prstGeom prst="rect">
-            <a:avLst/>
-          </a:prstGeom>
-          <a:solidFill>
-            <a:srgbClr val="2A2F3E"/>
-          </a:solidFill>
-          <a:ln>
-            <a:noFill/>
-          </a:ln>
-        </p:spPr>
-        <p:style>
-          <a:lnRef idx="1">
-            <a:schemeClr val="accent1"/>
-          </a:lnRef>
-          <a:fillRef idx="3">
-            <a:schemeClr val="accent1"/>
-          </a:fillRef>
-          <a:effectRef idx="2">
-            <a:schemeClr val="accent1"/>
-          </a:effectRef>
-          <a:fontRef idx="minor">
-            <a:schemeClr val="lt1"/>
-          </a:fontRef>
-        </p:style>
-        <p:txBody>
-          <a:bodyPr rtlCol="0" anchor="ctr"/>
-          <a:lstStyle/>
-          <a:p>
-            <a:pPr algn="ctr"/>
-          </a:p>
-        </p:txBody>
-      </p:sp>
-      <p:sp>
-        <p:nvSpPr>
-          <p:cNvPr id="21" name="TextBox 20"/>
-          <p:cNvSpPr txBox="1"/>
-          <p:nvPr/>
-        </p:nvSpPr>
-        <p:spPr>
-          <a:xfrm>
-            <a:off x="9189719" y="2103120"/>
-            <a:ext cx="2514600" cy="1097280"/>
-          </a:xfrm>
-          <a:prstGeom prst="rect">
-            <a:avLst/>
-          </a:prstGeom>
-          <a:noFill/>
-        </p:spPr>
-        <p:txBody>
-          <a:bodyPr wrap="square"/>
-          <a:lstStyle/>
-          <a:p>
-            <a:pPr algn="ctr">
-              <a:spcBef>
-                <a:spcPts val="200"/>
-              </a:spcBef>
-              <a:spcAft>
-                <a:spcPts val="200"/>
-              </a:spcAft>
-              <a:defRPr sz="5600" b="1" i="0">
-                <a:solidFill>
-                  <a:srgbClr val="FF1744"/>
-                </a:solidFill>
-                <a:latin typeface="Inter"/>
-              </a:defRPr>
-            </a:pPr>
-            <a:r>
-              <a:t>≈ 0</a:t>
-            </a:r>
-          </a:p>
-        </p:txBody>
-      </p:sp>
-      <p:sp>
-        <p:nvSpPr>
-          <p:cNvPr id="22" name="TextBox 21"/>
-          <p:cNvSpPr txBox="1"/>
-          <p:nvPr/>
-        </p:nvSpPr>
-        <p:spPr>
-          <a:xfrm>
-            <a:off x="9281159" y="3291840"/>
-            <a:ext cx="2331720" cy="2286000"/>
-          </a:xfrm>
-          <a:prstGeom prst="rect">
-            <a:avLst/>
-          </a:prstGeom>
-          <a:noFill/>
-        </p:spPr>
-        <p:txBody>
-          <a:bodyPr wrap="square"/>
-          <a:lstStyle/>
-          <a:p>
-            <a:pPr algn="ctr">
-              <a:spcBef>
-                <a:spcPts val="200"/>
-              </a:spcBef>
-              <a:spcAft>
-                <a:spcPts val="200"/>
-              </a:spcAft>
-              <a:defRPr sz="1500" b="0" i="0">
-                <a:solidFill>
-                  <a:srgbClr val="B0B0B0"/>
-                </a:solidFill>
-                <a:latin typeface="Inter"/>
-              </a:defRPr>
-            </a:pPr>
-            <a:r>
-              <a:t>Machine 22W, 6,9 g CO₂</a:t>
-            </a:r>
-          </a:p>
-          <a:p>
-            <a:pPr algn="ctr">
-              <a:spcBef>
-                <a:spcPts val="200"/>
-              </a:spcBef>
-              <a:spcAft>
-                <a:spcPts val="200"/>
-              </a:spcAft>
-              <a:defRPr sz="1500" b="0" i="0">
-                <a:solidFill>
-                  <a:srgbClr val="B0B0B0"/>
-                </a:solidFill>
-                <a:latin typeface="Inter"/>
-              </a:defRPr>
-            </a:pPr>
-            <a:r>
-              <a:t>Coût marginal/post ≈ 0</a:t>
-            </a:r>
-          </a:p>
-          <a:p>
-            <a:pPr algn="ctr">
-              <a:spcBef>
-                <a:spcPts val="200"/>
-              </a:spcBef>
-              <a:spcAft>
-                <a:spcPts val="200"/>
-              </a:spcAft>
-              <a:defRPr sz="1500" b="0" i="0">
-                <a:solidFill>
-                  <a:srgbClr val="B0B0B0"/>
-                </a:solidFill>
-                <a:latin typeface="Inter"/>
-              </a:defRPr>
-            </a:pPr>
-            <a:r>
-              <a:t>Aucune GPU cloud requise</a:t>
-            </a:r>
-          </a:p>
-        </p:txBody>
-      </p:sp>
-      <p:sp>
-        <p:nvSpPr>
-          <p:cNvPr id="23" name="TextBox 22"/>
-          <p:cNvSpPr txBox="1"/>
-          <p:nvPr/>
-        </p:nvSpPr>
-        <p:spPr>
-          <a:xfrm>
-            <a:off x="457200" y="6263640"/>
-            <a:ext cx="11247120" cy="274320"/>
-          </a:xfrm>
-          <a:prstGeom prst="rect">
-            <a:avLst/>
-          </a:prstGeom>
-          <a:noFill/>
-        </p:spPr>
-        <p:txBody>
-          <a:bodyPr wrap="square"/>
-          <a:lstStyle/>
-          <a:p>
-            <a:pPr algn="ctr">
-              <a:spcBef>
-                <a:spcPts val="200"/>
-              </a:spcBef>
-              <a:spcAft>
-                <a:spcPts val="200"/>
-              </a:spcAft>
-              <a:defRPr sz="1500" b="0" i="1">
+              <a:defRPr sz="1200" b="0" i="1">
                 <a:solidFill>
                   <a:srgbClr val="606060"/>
                 </a:solidFill>
@@ -12457,14 +13038,14 @@
               </a:defRPr>
             </a:pPr>
             <a:r>
-              <a:t>Niamato Consulting — Thumalien V9 : de l'analyse à la décision en 1,5 ms</a:t>
-            </a:r>
-          </a:p>
-        </p:txBody>
-      </p:sp>
-      <p:sp>
-        <p:nvSpPr>
-          <p:cNvPr id="24" name="TextBox 23"/>
+              <a:t>TJM consultant junior : 450 €  |  Stack : Python, PyTorch, Streamlit, Docker (OSS)</a:t>
+            </a:r>
+          </a:p>
+        </p:txBody>
+      </p:sp>
+      <p:sp>
+        <p:nvSpPr>
+          <p:cNvPr id="41" name="TextBox 40"/>
           <p:cNvSpPr txBox="1"/>
           <p:nvPr/>
         </p:nvSpPr>
@@ -12500,7 +13081,7 @@
       </p:sp>
       <p:sp>
         <p:nvSpPr>
-          <p:cNvPr id="25" name="TextBox 24"/>
+          <p:cNvPr id="42" name="TextBox 41"/>
           <p:cNvSpPr txBox="1"/>
           <p:nvPr/>
         </p:nvSpPr>

</xml_diff>